<commit_message>
test(corpus): rebuild the Office and PDF corpus with stable LibreOffice 24.2
Regenerate the 34 DOCX, XLSX, PPTX, ODT, ODS, ODP and PDF fixtures with a
stable LibreOffice release, record reproducibility (timestamps and
tool-generated IDs only), list every file's requirement in the README,
and run the build script's tests in verify.
</commit_message>
<xml_diff>
--- a/corpus/pptx/deck-12-slides.pptx
+++ b/corpus/pptx/deck-12-slides.pptx
@@ -45,7 +45,7 @@
       </p:grpSpPr>
       <p:sp>
         <p:nvSpPr>
-          <p:cNvPr id="9" name="PlaceHolder 1"/>
+          <p:cNvPr id="7" name="PlaceHolder 1"/>
           <p:cNvSpPr>
             <a:spLocks noGrp="1"/>
           </p:cNvSpPr>
@@ -67,36 +67,32 @@
           </a:ln>
         </p:spPr>
         <p:txBody>
-          <a:bodyPr lIns="0" tIns="0" rIns="0" bIns="0" anchor="ctr">
+          <a:bodyPr lIns="0" rIns="0" tIns="0" bIns="0" anchor="ctr">
             <a:noAutofit/>
           </a:bodyPr>
           <a:p>
             <a:pPr algn="ctr"/>
             <a:r>
-              <a:rPr lang="en-US" sz="4400" b="0" u="none" strike="noStrike">
-                <a:solidFill>
-                  <a:srgbClr val="000000"/>
-                </a:solidFill>
-                <a:effectLst/>
-                <a:uFillTx/>
+              <a:rPr b="0" lang="en-US" sz="4400" spc="-1" strike="noStrike">
+                <a:solidFill>
+                  <a:srgbClr val="000000"/>
+                </a:solidFill>
                 <a:latin typeface="Arial"/>
               </a:rPr>
               <a:t>Click to move the slide</a:t>
             </a:r>
-            <a:endParaRPr lang="en-US" sz="4400" b="0" u="none" strike="noStrike">
-              <a:solidFill>
-                <a:srgbClr val="000000"/>
-              </a:solidFill>
-              <a:effectLst/>
-              <a:uFillTx/>
-              <a:latin typeface="Arial"/>
-            </a:endParaRPr>
-          </a:p>
-        </p:txBody>
-      </p:sp>
-      <p:sp>
-        <p:nvSpPr>
-          <p:cNvPr id="10" name="PlaceHolder 2"/>
+            <a:endParaRPr b="0" lang="en-US" sz="4400" spc="-1" strike="noStrike">
+              <a:solidFill>
+                <a:srgbClr val="000000"/>
+              </a:solidFill>
+              <a:latin typeface="Arial"/>
+            </a:endParaRPr>
+          </a:p>
+        </p:txBody>
+      </p:sp>
+      <p:sp>
+        <p:nvSpPr>
+          <p:cNvPr id="8" name="PlaceHolder 2"/>
           <p:cNvSpPr>
             <a:spLocks noGrp="1"/>
           </p:cNvSpPr>
@@ -118,38 +114,34 @@
           </a:ln>
         </p:spPr>
         <p:txBody>
-          <a:bodyPr lIns="0" tIns="0" rIns="0" bIns="0" anchor="t">
-            <a:noAutofit/>
-          </a:bodyPr>
-          <a:p>
-            <a:pPr indent="0" algn="l">
+          <a:bodyPr lIns="0" rIns="0" tIns="0" bIns="0" anchor="t">
+            <a:noAutofit/>
+          </a:bodyPr>
+          <a:p>
+            <a:pPr marL="216000" indent="-216000">
               <a:buNone/>
             </a:pPr>
             <a:r>
-              <a:rPr lang="en-US" sz="2000" b="0" u="none" strike="noStrike">
-                <a:solidFill>
-                  <a:srgbClr val="000000"/>
-                </a:solidFill>
-                <a:effectLst/>
-                <a:uFillTx/>
+              <a:rPr b="0" lang="en-US" sz="2000" spc="-1" strike="noStrike">
+                <a:solidFill>
+                  <a:srgbClr val="000000"/>
+                </a:solidFill>
                 <a:latin typeface="Arial"/>
               </a:rPr>
               <a:t>Click to edit the notes format</a:t>
             </a:r>
-            <a:endParaRPr lang="en-US" sz="2000" b="0" u="none" strike="noStrike">
-              <a:solidFill>
-                <a:srgbClr val="000000"/>
-              </a:solidFill>
-              <a:effectLst/>
-              <a:uFillTx/>
-              <a:latin typeface="Arial"/>
-            </a:endParaRPr>
-          </a:p>
-        </p:txBody>
-      </p:sp>
-      <p:sp>
-        <p:nvSpPr>
-          <p:cNvPr id="11" name="PlaceHolder 3"/>
+            <a:endParaRPr b="0" lang="en-US" sz="2000" spc="-1" strike="noStrike">
+              <a:solidFill>
+                <a:srgbClr val="000000"/>
+              </a:solidFill>
+              <a:latin typeface="Arial"/>
+            </a:endParaRPr>
+          </a:p>
+        </p:txBody>
+      </p:sp>
+      <p:sp>
+        <p:nvSpPr>
+          <p:cNvPr id="9" name="PlaceHolder 3"/>
           <p:cNvSpPr>
             <a:spLocks noGrp="1"/>
           </p:cNvSpPr>
@@ -171,30 +163,26 @@
           </a:ln>
         </p:spPr>
         <p:txBody>
-          <a:bodyPr lIns="0" tIns="0" rIns="0" bIns="0" anchor="t">
-            <a:noAutofit/>
-          </a:bodyPr>
-          <a:p>
-            <a:pPr indent="0" algn="l">
+          <a:bodyPr lIns="0" rIns="0" tIns="0" bIns="0" anchor="t">
+            <a:noAutofit/>
+          </a:bodyPr>
+          <a:p>
+            <a:pPr indent="0">
               <a:buNone/>
             </a:pPr>
             <a:r>
-              <a:rPr lang="en-US" sz="1400" b="0" u="none" strike="noStrike">
-                <a:solidFill>
-                  <a:srgbClr val="000000"/>
-                </a:solidFill>
-                <a:effectLst/>
-                <a:uFillTx/>
+              <a:rPr b="0" lang="en-US" sz="1400" spc="-1" strike="noStrike">
+                <a:solidFill>
+                  <a:srgbClr val="000000"/>
+                </a:solidFill>
                 <a:latin typeface="Times New Roman"/>
               </a:rPr>
               <a:t>&lt;header&gt;</a:t>
             </a:r>
-            <a:endParaRPr lang="en-US" sz="1400" b="0" u="none" strike="noStrike">
-              <a:solidFill>
-                <a:srgbClr val="000000"/>
-              </a:solidFill>
-              <a:effectLst/>
-              <a:uFillTx/>
+            <a:endParaRPr b="0" lang="en-US" sz="1400" spc="-1" strike="noStrike">
+              <a:solidFill>
+                <a:srgbClr val="000000"/>
+              </a:solidFill>
               <a:latin typeface="Times New Roman"/>
             </a:endParaRPr>
           </a:p>
@@ -202,7 +190,7 @@
       </p:sp>
       <p:sp>
         <p:nvSpPr>
-          <p:cNvPr id="12" name="PlaceHolder 4"/>
+          <p:cNvPr id="10" name="PlaceHolder 4"/>
           <p:cNvSpPr>
             <a:spLocks noGrp="1"/>
           </p:cNvSpPr>
@@ -224,18 +212,16 @@
           </a:ln>
         </p:spPr>
         <p:txBody>
-          <a:bodyPr lIns="0" tIns="0" rIns="0" bIns="0" anchor="t">
+          <a:bodyPr lIns="0" rIns="0" tIns="0" bIns="0" anchor="t">
             <a:noAutofit/>
           </a:bodyPr>
           <a:lstStyle>
             <a:lvl1pPr indent="0" algn="r">
               <a:buNone/>
-              <a:defRPr lang="en-US" sz="1400" b="0" u="none" strike="noStrike">
-                <a:solidFill>
-                  <a:srgbClr val="000000"/>
-                </a:solidFill>
-                <a:effectLst/>
-                <a:uFillTx/>
+              <a:defRPr b="0" lang="en-US" sz="1400" spc="-1" strike="noStrike">
+                <a:solidFill>
+                  <a:srgbClr val="000000"/>
+                </a:solidFill>
                 <a:latin typeface="Times New Roman"/>
               </a:defRPr>
             </a:lvl1pPr>
@@ -245,22 +231,18 @@
               <a:buNone/>
             </a:pPr>
             <a:r>
-              <a:rPr lang="en-US" sz="1400" b="0" u="none" strike="noStrike">
-                <a:solidFill>
-                  <a:srgbClr val="000000"/>
-                </a:solidFill>
-                <a:effectLst/>
-                <a:uFillTx/>
+              <a:rPr b="0" lang="en-US" sz="1400" spc="-1" strike="noStrike">
+                <a:solidFill>
+                  <a:srgbClr val="000000"/>
+                </a:solidFill>
                 <a:latin typeface="Times New Roman"/>
               </a:rPr>
               <a:t>&lt;date/time&gt;</a:t>
             </a:r>
-            <a:endParaRPr lang="en-US" sz="1400" b="0" u="none" strike="noStrike">
-              <a:solidFill>
-                <a:srgbClr val="000000"/>
-              </a:solidFill>
-              <a:effectLst/>
-              <a:uFillTx/>
+            <a:endParaRPr b="0" lang="en-US" sz="1400" spc="-1" strike="noStrike">
+              <a:solidFill>
+                <a:srgbClr val="000000"/>
+              </a:solidFill>
               <a:latin typeface="Times New Roman"/>
             </a:endParaRPr>
           </a:p>
@@ -268,7 +250,7 @@
       </p:sp>
       <p:sp>
         <p:nvSpPr>
-          <p:cNvPr id="13" name="PlaceHolder 5"/>
+          <p:cNvPr id="11" name="PlaceHolder 5"/>
           <p:cNvSpPr>
             <a:spLocks noGrp="1"/>
           </p:cNvSpPr>
@@ -290,43 +272,37 @@
           </a:ln>
         </p:spPr>
         <p:txBody>
-          <a:bodyPr lIns="0" tIns="0" rIns="0" bIns="0" anchor="b">
+          <a:bodyPr lIns="0" rIns="0" tIns="0" bIns="0" anchor="b">
             <a:noAutofit/>
           </a:bodyPr>
           <a:lstStyle>
-            <a:lvl1pPr indent="0" algn="l">
+            <a:lvl1pPr indent="0">
               <a:buNone/>
-              <a:defRPr lang="en-US" sz="1400" b="0" u="none" strike="noStrike">
-                <a:solidFill>
-                  <a:srgbClr val="000000"/>
-                </a:solidFill>
-                <a:effectLst/>
-                <a:uFillTx/>
+              <a:defRPr b="0" lang="en-US" sz="1400" spc="-1" strike="noStrike">
+                <a:solidFill>
+                  <a:srgbClr val="000000"/>
+                </a:solidFill>
                 <a:latin typeface="Times New Roman"/>
               </a:defRPr>
             </a:lvl1pPr>
           </a:lstStyle>
           <a:p>
-            <a:pPr indent="0" algn="l">
+            <a:pPr indent="0">
               <a:buNone/>
             </a:pPr>
             <a:r>
-              <a:rPr lang="en-US" sz="1400" b="0" u="none" strike="noStrike">
-                <a:solidFill>
-                  <a:srgbClr val="000000"/>
-                </a:solidFill>
-                <a:effectLst/>
-                <a:uFillTx/>
+              <a:rPr b="0" lang="en-US" sz="1400" spc="-1" strike="noStrike">
+                <a:solidFill>
+                  <a:srgbClr val="000000"/>
+                </a:solidFill>
                 <a:latin typeface="Times New Roman"/>
               </a:rPr>
               <a:t>&lt;footer&gt;</a:t>
             </a:r>
-            <a:endParaRPr lang="en-US" sz="1400" b="0" u="none" strike="noStrike">
-              <a:solidFill>
-                <a:srgbClr val="000000"/>
-              </a:solidFill>
-              <a:effectLst/>
-              <a:uFillTx/>
+            <a:endParaRPr b="0" lang="en-US" sz="1400" spc="-1" strike="noStrike">
+              <a:solidFill>
+                <a:srgbClr val="000000"/>
+              </a:solidFill>
               <a:latin typeface="Times New Roman"/>
             </a:endParaRPr>
           </a:p>
@@ -334,7 +310,7 @@
       </p:sp>
       <p:sp>
         <p:nvSpPr>
-          <p:cNvPr id="14" name="PlaceHolder 6"/>
+          <p:cNvPr id="12" name="PlaceHolder 6"/>
           <p:cNvSpPr>
             <a:spLocks noGrp="1"/>
           </p:cNvSpPr>
@@ -356,18 +332,16 @@
           </a:ln>
         </p:spPr>
         <p:txBody>
-          <a:bodyPr lIns="0" tIns="0" rIns="0" bIns="0" anchor="b">
+          <a:bodyPr lIns="0" rIns="0" tIns="0" bIns="0" anchor="b">
             <a:noAutofit/>
           </a:bodyPr>
           <a:lstStyle>
             <a:lvl1pPr indent="0" algn="r">
               <a:buNone/>
-              <a:defRPr lang="en-US" sz="1400" b="0" u="none" strike="noStrike">
-                <a:solidFill>
-                  <a:srgbClr val="000000"/>
-                </a:solidFill>
-                <a:effectLst/>
-                <a:uFillTx/>
+              <a:defRPr b="0" lang="en-US" sz="1400" spc="-1" strike="noStrike">
+                <a:solidFill>
+                  <a:srgbClr val="000000"/>
+                </a:solidFill>
                 <a:latin typeface="Times New Roman"/>
               </a:defRPr>
             </a:lvl1pPr>
@@ -376,23 +350,19 @@
             <a:pPr indent="0" algn="r">
               <a:buNone/>
             </a:pPr>
-            <a:fld id="{A60F1A92-1D61-44B3-8777-2F92FA52FB02}" type="slidenum">
-              <a:rPr lang="en-US" sz="1400" b="0" u="none" strike="noStrike">
-                <a:solidFill>
-                  <a:srgbClr val="000000"/>
-                </a:solidFill>
-                <a:effectLst/>
-                <a:uFillTx/>
+            <a:fld id="{A254BC4C-D595-4AF8-8B44-01BA62102553}" type="slidenum">
+              <a:rPr b="0" lang="en-US" sz="1400" spc="-1" strike="noStrike">
+                <a:solidFill>
+                  <a:srgbClr val="000000"/>
+                </a:solidFill>
                 <a:latin typeface="Times New Roman"/>
               </a:rPr>
               <a:t>&lt;number&gt;</a:t>
             </a:fld>
-            <a:endParaRPr lang="en-US" sz="1400" b="0" u="none" strike="noStrike">
-              <a:solidFill>
-                <a:srgbClr val="000000"/>
-              </a:solidFill>
-              <a:effectLst/>
-              <a:uFillTx/>
+            <a:endParaRPr b="0" lang="en-US" sz="1400" spc="-1" strike="noStrike">
+              <a:solidFill>
+                <a:srgbClr val="000000"/>
+              </a:solidFill>
               <a:latin typeface="Times New Roman"/>
             </a:endParaRPr>
           </a:p>
@@ -423,7 +393,7 @@
       </p:grpSpPr>
       <p:sp>
         <p:nvSpPr>
-          <p:cNvPr id="40" name=""/>
+          <p:cNvPr id="38" name=""/>
           <p:cNvSpPr txBox="1"/>
           <p:nvPr/>
         </p:nvSpPr>
@@ -436,41 +406,32 @@
             <a:avLst/>
           </a:prstGeom>
           <a:solidFill>
-            <a:schemeClr val="accent1"/>
+            <a:srgbClr val="729fcf"/>
           </a:solidFill>
-          <a:ln w="38160">
+          <a:ln w="0">
             <a:solidFill>
-              <a:schemeClr val="accent1">
-                <a:lumMod val="75000"/>
-                <a:lumOff val="0"/>
-              </a:schemeClr>
+              <a:srgbClr val="3465a4"/>
             </a:solidFill>
-            <a:round/>
-          </a:ln>
-        </p:spPr>
-        <p:txBody>
-          <a:bodyPr lIns="90000" tIns="45000" rIns="90000" bIns="45000" anchor="t">
-            <a:spAutoFit/>
-          </a:bodyPr>
-          <a:p>
-            <a:pPr/>
-            <a:r>
-              <a:rPr lang="en-US" sz="1800" b="0" u="none" strike="noStrike">
-                <a:solidFill>
-                  <a:srgbClr val="FFFFFF"/>
-                </a:solidFill>
-                <a:effectLst/>
-                <a:uFillTx/>
+          </a:ln>
+        </p:spPr>
+        <p:txBody>
+          <a:bodyPr lIns="90000" rIns="90000" tIns="45000" bIns="45000" anchor="t">
+            <a:noAutofit/>
+          </a:bodyPr>
+          <a:p>
+            <a:r>
+              <a:rPr b="0" lang="en-US" sz="1800" spc="-1" strike="noStrike">
+                <a:solidFill>
+                  <a:srgbClr val="000000"/>
+                </a:solidFill>
                 <a:latin typeface="Arial"/>
               </a:rPr>
               <a:t>Speaker note: Introduce the synthetic shoreline survey.</a:t>
             </a:r>
-            <a:endParaRPr lang="en-US" sz="1800" b="0" u="none" strike="noStrike">
-              <a:solidFill>
-                <a:srgbClr val="FFFFFF"/>
-              </a:solidFill>
-              <a:effectLst/>
-              <a:uFillTx/>
+            <a:endParaRPr b="0" lang="en-US" sz="1800" spc="-1" strike="noStrike">
+              <a:solidFill>
+                <a:srgbClr val="000000"/>
+              </a:solidFill>
               <a:latin typeface="Arial"/>
             </a:endParaRPr>
           </a:p>
@@ -532,7 +493,7 @@
         <p:txBody>
           <a:bodyPr/>
           <a:p>
-            <a:fld id="{9A81AFD7-1A7E-4CA3-92C9-CE715535458C}" type="slidenum">
+            <a:fld id="{DDDD7154-920A-42AE-A544-68C4CDC53EDA}" type="slidenum">
               <a:t>&lt;#&gt;</a:t>
             </a:fld>
           </a:p>
@@ -583,7 +544,7 @@
       </p:grpSpPr>
       <p:sp>
         <p:nvSpPr>
-          <p:cNvPr id="7" name="PlaceHolder 1"/>
+          <p:cNvPr id="5" name="PlaceHolder 1"/>
           <p:cNvSpPr>
             <a:spLocks noGrp="1"/>
           </p:cNvSpPr>
@@ -605,27 +566,25 @@
           </a:ln>
         </p:spPr>
         <p:txBody>
-          <a:bodyPr lIns="0" tIns="0" rIns="0" bIns="0" anchor="ctr">
-            <a:spAutoFit/>
+          <a:bodyPr lIns="0" rIns="0" tIns="0" bIns="0" anchor="ctr">
+            <a:noAutofit/>
           </a:bodyPr>
           <a:p>
             <a:pPr indent="0" algn="ctr">
               <a:buNone/>
             </a:pPr>
-            <a:endParaRPr lang="en-US" sz="4400" b="0" u="none" strike="noStrike">
-              <a:solidFill>
-                <a:srgbClr val="000000"/>
-              </a:solidFill>
-              <a:effectLst/>
-              <a:uFillTx/>
-              <a:latin typeface="Arial"/>
-            </a:endParaRPr>
-          </a:p>
-        </p:txBody>
-      </p:sp>
-      <p:sp>
-        <p:nvSpPr>
-          <p:cNvPr id="8" name="PlaceHolder 2"/>
+            <a:endParaRPr b="0" lang="en-US" sz="4400" spc="-1" strike="noStrike">
+              <a:solidFill>
+                <a:srgbClr val="000000"/>
+              </a:solidFill>
+              <a:latin typeface="Arial"/>
+            </a:endParaRPr>
+          </a:p>
+        </p:txBody>
+      </p:sp>
+      <p:sp>
+        <p:nvSpPr>
+          <p:cNvPr id="6" name="PlaceHolder 2"/>
           <p:cNvSpPr>
             <a:spLocks noGrp="1"/>
           </p:cNvSpPr>
@@ -647,19 +606,17 @@
           </a:ln>
         </p:spPr>
         <p:txBody>
-          <a:bodyPr lIns="0" tIns="0" rIns="0" bIns="0" anchor="ctr">
-            <a:spAutoFit/>
+          <a:bodyPr lIns="0" rIns="0" tIns="0" bIns="0" anchor="ctr">
+            <a:noAutofit/>
           </a:bodyPr>
           <a:p>
             <a:pPr indent="0" algn="ctr">
               <a:buNone/>
             </a:pPr>
-            <a:endParaRPr lang="en-US" sz="3200" b="0" u="none" strike="noStrike">
-              <a:solidFill>
-                <a:srgbClr val="000000"/>
-              </a:solidFill>
-              <a:effectLst/>
-              <a:uFillTx/>
+            <a:endParaRPr b="0" lang="en-US" sz="3200" spc="-1" strike="noStrike">
+              <a:solidFill>
+                <a:srgbClr val="000000"/>
+              </a:solidFill>
               <a:latin typeface="Arial"/>
             </a:endParaRPr>
           </a:p>
@@ -699,7 +656,7 @@
         <p:txBody>
           <a:bodyPr/>
           <a:p>
-            <a:fld id="{E9C37EE5-EB15-461D-B92B-564186B7CA68}" type="slidenum">
+            <a:fld id="{8A5FB980-966D-412A-BB86-B1221285CC59}" type="slidenum">
               <a:t>&lt;#&gt;</a:t>
             </a:fld>
           </a:p>
@@ -750,7 +707,7 @@
       </p:grpSpPr>
       <p:sp>
         <p:nvSpPr>
-          <p:cNvPr id="2" name="PlaceHolder 1"/>
+          <p:cNvPr id="0" name="PlaceHolder 1"/>
           <p:cNvSpPr>
             <a:spLocks noGrp="1"/>
           </p:cNvSpPr>
@@ -772,51 +729,34 @@
           </a:ln>
         </p:spPr>
         <p:txBody>
-          <a:bodyPr lIns="0" tIns="0" rIns="0" bIns="0" anchor="ctr">
-            <a:noAutofit/>
-          </a:bodyPr>
-          <a:lstStyle>
-            <a:lvl1pPr indent="0" algn="ctr">
-              <a:buNone/>
-              <a:defRPr lang="en-US" sz="4400" b="0" u="none" strike="noStrike">
-                <a:solidFill>
-                  <a:srgbClr val="000000"/>
-                </a:solidFill>
-                <a:effectLst/>
-                <a:uFillTx/>
-                <a:latin typeface="Arial"/>
-              </a:defRPr>
-            </a:lvl1pPr>
-          </a:lstStyle>
+          <a:bodyPr lIns="0" rIns="0" tIns="0" bIns="0" anchor="ctr">
+            <a:noAutofit/>
+          </a:bodyPr>
           <a:p>
             <a:pPr indent="0" algn="ctr">
               <a:buNone/>
             </a:pPr>
             <a:r>
-              <a:rPr lang="en-US" sz="4400" b="0" u="none" strike="noStrike">
-                <a:solidFill>
-                  <a:srgbClr val="000000"/>
-                </a:solidFill>
-                <a:effectLst/>
-                <a:uFillTx/>
+              <a:rPr b="0" lang="en-US" sz="4400" spc="-1" strike="noStrike">
+                <a:solidFill>
+                  <a:srgbClr val="000000"/>
+                </a:solidFill>
                 <a:latin typeface="Arial"/>
               </a:rPr>
               <a:t>Click to edit the title text format</a:t>
             </a:r>
-            <a:endParaRPr lang="en-US" sz="4400" b="0" u="none" strike="noStrike">
-              <a:solidFill>
-                <a:srgbClr val="000000"/>
-              </a:solidFill>
-              <a:effectLst/>
-              <a:uFillTx/>
-              <a:latin typeface="Arial"/>
-            </a:endParaRPr>
-          </a:p>
-        </p:txBody>
-      </p:sp>
-      <p:sp>
-        <p:nvSpPr>
-          <p:cNvPr id="3" name="PlaceHolder 2"/>
+            <a:endParaRPr b="0" lang="en-US" sz="4400" spc="-1" strike="noStrike">
+              <a:solidFill>
+                <a:srgbClr val="000000"/>
+              </a:solidFill>
+              <a:latin typeface="Arial"/>
+            </a:endParaRPr>
+          </a:p>
+        </p:txBody>
+      </p:sp>
+      <p:sp>
+        <p:nvSpPr>
+          <p:cNvPr id="1" name="PlaceHolder 2"/>
           <p:cNvSpPr>
             <a:spLocks noGrp="1"/>
           </p:cNvSpPr>
@@ -838,146 +778,11 @@
           </a:ln>
         </p:spPr>
         <p:txBody>
-          <a:bodyPr lIns="0" tIns="0" rIns="0" bIns="0" anchor="t">
+          <a:bodyPr lIns="0" rIns="0" tIns="0" bIns="0" anchor="t">
             <a:normAutofit/>
           </a:bodyPr>
-          <a:lstStyle>
-            <a:lvl1pPr algn="l">
-              <a:spcBef>
-                <a:spcPts val="1417"/>
-              </a:spcBef>
-              <a:buClr>
-                <a:srgbClr val="000000"/>
-              </a:buClr>
-              <a:buSzPct val="45000"/>
-              <a:buFont typeface="Wingdings" charset="2"/>
-              <a:buChar char=""/>
-              <a:defRPr lang="en-US" sz="3200" b="0" u="none" strike="noStrike">
-                <a:solidFill>
-                  <a:srgbClr val="000000"/>
-                </a:solidFill>
-                <a:effectLst/>
-                <a:uFillTx/>
-                <a:latin typeface="Arial"/>
-              </a:defRPr>
-            </a:lvl1pPr>
-            <a:lvl2pPr lvl="1" algn="l">
-              <a:spcBef>
-                <a:spcPts val="1134"/>
-              </a:spcBef>
-              <a:buClr>
-                <a:srgbClr val="000000"/>
-              </a:buClr>
-              <a:buSzPct val="75000"/>
-              <a:buFont typeface="Symbol" charset="2"/>
-              <a:buChar char=""/>
-              <a:defRPr lang="en-US" sz="2800" b="0" u="none" strike="noStrike">
-                <a:solidFill>
-                  <a:srgbClr val="000000"/>
-                </a:solidFill>
-                <a:effectLst/>
-                <a:uFillTx/>
-                <a:latin typeface="Arial"/>
-              </a:defRPr>
-            </a:lvl2pPr>
-            <a:lvl3pPr lvl="2" algn="l">
-              <a:spcBef>
-                <a:spcPts val="850"/>
-              </a:spcBef>
-              <a:buClr>
-                <a:srgbClr val="000000"/>
-              </a:buClr>
-              <a:buSzPct val="45000"/>
-              <a:buFont typeface="Wingdings" charset="2"/>
-              <a:buChar char=""/>
-              <a:defRPr lang="en-US" sz="2400" b="0" u="none" strike="noStrike">
-                <a:solidFill>
-                  <a:srgbClr val="000000"/>
-                </a:solidFill>
-                <a:effectLst/>
-                <a:uFillTx/>
-                <a:latin typeface="Arial"/>
-              </a:defRPr>
-            </a:lvl3pPr>
-            <a:lvl4pPr lvl="3" algn="l">
-              <a:spcBef>
-                <a:spcPts val="567"/>
-              </a:spcBef>
-              <a:buClr>
-                <a:srgbClr val="000000"/>
-              </a:buClr>
-              <a:buSzPct val="75000"/>
-              <a:buFont typeface="Symbol" charset="2"/>
-              <a:buChar char=""/>
-              <a:defRPr lang="en-US" sz="2000" b="0" u="none" strike="noStrike">
-                <a:solidFill>
-                  <a:srgbClr val="000000"/>
-                </a:solidFill>
-                <a:effectLst/>
-                <a:uFillTx/>
-                <a:latin typeface="Arial"/>
-              </a:defRPr>
-            </a:lvl4pPr>
-            <a:lvl5pPr lvl="4" algn="l">
-              <a:spcBef>
-                <a:spcPts val="283"/>
-              </a:spcBef>
-              <a:buClr>
-                <a:srgbClr val="000000"/>
-              </a:buClr>
-              <a:buSzPct val="45000"/>
-              <a:buFont typeface="Wingdings" charset="2"/>
-              <a:buChar char=""/>
-              <a:defRPr lang="en-US" sz="2000" b="0" u="none" strike="noStrike">
-                <a:solidFill>
-                  <a:srgbClr val="000000"/>
-                </a:solidFill>
-                <a:effectLst/>
-                <a:uFillTx/>
-                <a:latin typeface="Arial"/>
-              </a:defRPr>
-            </a:lvl5pPr>
-            <a:lvl6pPr lvl="5" algn="l">
-              <a:spcBef>
-                <a:spcPts val="283"/>
-              </a:spcBef>
-              <a:buClr>
-                <a:srgbClr val="000000"/>
-              </a:buClr>
-              <a:buSzPct val="45000"/>
-              <a:buFont typeface="Wingdings" charset="2"/>
-              <a:buChar char=""/>
-              <a:defRPr lang="en-US" sz="2000" b="0" u="none" strike="noStrike">
-                <a:solidFill>
-                  <a:srgbClr val="000000"/>
-                </a:solidFill>
-                <a:effectLst/>
-                <a:uFillTx/>
-                <a:latin typeface="Arial"/>
-              </a:defRPr>
-            </a:lvl6pPr>
-            <a:lvl7pPr lvl="6" algn="l">
-              <a:spcBef>
-                <a:spcPts val="283"/>
-              </a:spcBef>
-              <a:buClr>
-                <a:srgbClr val="000000"/>
-              </a:buClr>
-              <a:buSzPct val="45000"/>
-              <a:buFont typeface="Wingdings" charset="2"/>
-              <a:buChar char=""/>
-              <a:defRPr lang="en-US" sz="2000" b="0" u="none" strike="noStrike">
-                <a:solidFill>
-                  <a:srgbClr val="000000"/>
-                </a:solidFill>
-                <a:effectLst/>
-                <a:uFillTx/>
-                <a:latin typeface="Arial"/>
-              </a:defRPr>
-            </a:lvl7pPr>
-          </a:lstStyle>
-          <a:p>
-            <a:pPr marL="432000" indent="-324000" algn="l">
+          <a:p>
+            <a:pPr marL="432000" indent="-324000">
               <a:spcBef>
                 <a:spcPts val="1417"/>
               </a:spcBef>
@@ -989,27 +794,23 @@
               <a:buChar char=""/>
             </a:pPr>
             <a:r>
-              <a:rPr lang="en-US" sz="3200" b="0" u="none" strike="noStrike">
-                <a:solidFill>
-                  <a:srgbClr val="000000"/>
-                </a:solidFill>
-                <a:effectLst/>
-                <a:uFillTx/>
+              <a:rPr b="0" lang="en-US" sz="3200" spc="-1" strike="noStrike">
+                <a:solidFill>
+                  <a:srgbClr val="000000"/>
+                </a:solidFill>
                 <a:latin typeface="Arial"/>
               </a:rPr>
               <a:t>Click to edit the outline text format</a:t>
             </a:r>
-            <a:endParaRPr lang="en-US" sz="3200" b="0" u="none" strike="noStrike">
-              <a:solidFill>
-                <a:srgbClr val="000000"/>
-              </a:solidFill>
-              <a:effectLst/>
-              <a:uFillTx/>
-              <a:latin typeface="Arial"/>
-            </a:endParaRPr>
-          </a:p>
-          <a:p>
-            <a:pPr marL="864000" lvl="1" indent="-324000" algn="l">
+            <a:endParaRPr b="0" lang="en-US" sz="3200" spc="-1" strike="noStrike">
+              <a:solidFill>
+                <a:srgbClr val="000000"/>
+              </a:solidFill>
+              <a:latin typeface="Arial"/>
+            </a:endParaRPr>
+          </a:p>
+          <a:p>
+            <a:pPr lvl="1" marL="864000" indent="-324000">
               <a:spcBef>
                 <a:spcPts val="1134"/>
               </a:spcBef>
@@ -1021,27 +822,23 @@
               <a:buChar char=""/>
             </a:pPr>
             <a:r>
-              <a:rPr lang="en-US" sz="2800" b="0" u="none" strike="noStrike">
-                <a:solidFill>
-                  <a:srgbClr val="000000"/>
-                </a:solidFill>
-                <a:effectLst/>
-                <a:uFillTx/>
+              <a:rPr b="0" lang="en-US" sz="2800" spc="-1" strike="noStrike">
+                <a:solidFill>
+                  <a:srgbClr val="000000"/>
+                </a:solidFill>
                 <a:latin typeface="Arial"/>
               </a:rPr>
               <a:t>Second Outline Level</a:t>
             </a:r>
-            <a:endParaRPr lang="en-US" sz="2800" b="0" u="none" strike="noStrike">
-              <a:solidFill>
-                <a:srgbClr val="000000"/>
-              </a:solidFill>
-              <a:effectLst/>
-              <a:uFillTx/>
-              <a:latin typeface="Arial"/>
-            </a:endParaRPr>
-          </a:p>
-          <a:p>
-            <a:pPr marL="1296000" lvl="2" indent="-288000" algn="l">
+            <a:endParaRPr b="0" lang="en-US" sz="2800" spc="-1" strike="noStrike">
+              <a:solidFill>
+                <a:srgbClr val="000000"/>
+              </a:solidFill>
+              <a:latin typeface="Arial"/>
+            </a:endParaRPr>
+          </a:p>
+          <a:p>
+            <a:pPr lvl="2" marL="1296000" indent="-288000">
               <a:spcBef>
                 <a:spcPts val="850"/>
               </a:spcBef>
@@ -1053,27 +850,23 @@
               <a:buChar char=""/>
             </a:pPr>
             <a:r>
-              <a:rPr lang="en-US" sz="2400" b="0" u="none" strike="noStrike">
-                <a:solidFill>
-                  <a:srgbClr val="000000"/>
-                </a:solidFill>
-                <a:effectLst/>
-                <a:uFillTx/>
+              <a:rPr b="0" lang="en-US" sz="2400" spc="-1" strike="noStrike">
+                <a:solidFill>
+                  <a:srgbClr val="000000"/>
+                </a:solidFill>
                 <a:latin typeface="Arial"/>
               </a:rPr>
               <a:t>Third Outline Level</a:t>
             </a:r>
-            <a:endParaRPr lang="en-US" sz="2400" b="0" u="none" strike="noStrike">
-              <a:solidFill>
-                <a:srgbClr val="000000"/>
-              </a:solidFill>
-              <a:effectLst/>
-              <a:uFillTx/>
-              <a:latin typeface="Arial"/>
-            </a:endParaRPr>
-          </a:p>
-          <a:p>
-            <a:pPr marL="1728000" lvl="3" indent="-216000" algn="l">
+            <a:endParaRPr b="0" lang="en-US" sz="2400" spc="-1" strike="noStrike">
+              <a:solidFill>
+                <a:srgbClr val="000000"/>
+              </a:solidFill>
+              <a:latin typeface="Arial"/>
+            </a:endParaRPr>
+          </a:p>
+          <a:p>
+            <a:pPr lvl="3" marL="1728000" indent="-216000">
               <a:spcBef>
                 <a:spcPts val="567"/>
               </a:spcBef>
@@ -1085,27 +878,23 @@
               <a:buChar char=""/>
             </a:pPr>
             <a:r>
-              <a:rPr lang="en-US" sz="2000" b="0" u="none" strike="noStrike">
-                <a:solidFill>
-                  <a:srgbClr val="000000"/>
-                </a:solidFill>
-                <a:effectLst/>
-                <a:uFillTx/>
+              <a:rPr b="0" lang="en-US" sz="2000" spc="-1" strike="noStrike">
+                <a:solidFill>
+                  <a:srgbClr val="000000"/>
+                </a:solidFill>
                 <a:latin typeface="Arial"/>
               </a:rPr>
               <a:t>Fourth Outline Level</a:t>
             </a:r>
-            <a:endParaRPr lang="en-US" sz="2000" b="0" u="none" strike="noStrike">
-              <a:solidFill>
-                <a:srgbClr val="000000"/>
-              </a:solidFill>
-              <a:effectLst/>
-              <a:uFillTx/>
-              <a:latin typeface="Arial"/>
-            </a:endParaRPr>
-          </a:p>
-          <a:p>
-            <a:pPr marL="2160000" lvl="4" indent="-216000" algn="l">
+            <a:endParaRPr b="0" lang="en-US" sz="2000" spc="-1" strike="noStrike">
+              <a:solidFill>
+                <a:srgbClr val="000000"/>
+              </a:solidFill>
+              <a:latin typeface="Arial"/>
+            </a:endParaRPr>
+          </a:p>
+          <a:p>
+            <a:pPr lvl="4" marL="2160000" indent="-216000">
               <a:spcBef>
                 <a:spcPts val="283"/>
               </a:spcBef>
@@ -1117,27 +906,23 @@
               <a:buChar char=""/>
             </a:pPr>
             <a:r>
-              <a:rPr lang="en-US" sz="2000" b="0" u="none" strike="noStrike">
-                <a:solidFill>
-                  <a:srgbClr val="000000"/>
-                </a:solidFill>
-                <a:effectLst/>
-                <a:uFillTx/>
+              <a:rPr b="0" lang="en-US" sz="2000" spc="-1" strike="noStrike">
+                <a:solidFill>
+                  <a:srgbClr val="000000"/>
+                </a:solidFill>
                 <a:latin typeface="Arial"/>
               </a:rPr>
               <a:t>Fifth Outline Level</a:t>
             </a:r>
-            <a:endParaRPr lang="en-US" sz="2000" b="0" u="none" strike="noStrike">
-              <a:solidFill>
-                <a:srgbClr val="000000"/>
-              </a:solidFill>
-              <a:effectLst/>
-              <a:uFillTx/>
-              <a:latin typeface="Arial"/>
-            </a:endParaRPr>
-          </a:p>
-          <a:p>
-            <a:pPr marL="2592000" lvl="5" indent="-216000" algn="l">
+            <a:endParaRPr b="0" lang="en-US" sz="2000" spc="-1" strike="noStrike">
+              <a:solidFill>
+                <a:srgbClr val="000000"/>
+              </a:solidFill>
+              <a:latin typeface="Arial"/>
+            </a:endParaRPr>
+          </a:p>
+          <a:p>
+            <a:pPr lvl="5" marL="2592000" indent="-216000">
               <a:spcBef>
                 <a:spcPts val="283"/>
               </a:spcBef>
@@ -1149,27 +934,23 @@
               <a:buChar char=""/>
             </a:pPr>
             <a:r>
-              <a:rPr lang="en-US" sz="2000" b="0" u="none" strike="noStrike">
-                <a:solidFill>
-                  <a:srgbClr val="000000"/>
-                </a:solidFill>
-                <a:effectLst/>
-                <a:uFillTx/>
+              <a:rPr b="0" lang="en-US" sz="2000" spc="-1" strike="noStrike">
+                <a:solidFill>
+                  <a:srgbClr val="000000"/>
+                </a:solidFill>
                 <a:latin typeface="Arial"/>
               </a:rPr>
               <a:t>Sixth Outline Level</a:t>
             </a:r>
-            <a:endParaRPr lang="en-US" sz="2000" b="0" u="none" strike="noStrike">
-              <a:solidFill>
-                <a:srgbClr val="000000"/>
-              </a:solidFill>
-              <a:effectLst/>
-              <a:uFillTx/>
-              <a:latin typeface="Arial"/>
-            </a:endParaRPr>
-          </a:p>
-          <a:p>
-            <a:pPr marL="3024000" lvl="6" indent="-216000" algn="l">
+            <a:endParaRPr b="0" lang="en-US" sz="2000" spc="-1" strike="noStrike">
+              <a:solidFill>
+                <a:srgbClr val="000000"/>
+              </a:solidFill>
+              <a:latin typeface="Arial"/>
+            </a:endParaRPr>
+          </a:p>
+          <a:p>
+            <a:pPr lvl="6" marL="3024000" indent="-216000">
               <a:spcBef>
                 <a:spcPts val="283"/>
               </a:spcBef>
@@ -1181,30 +962,26 @@
               <a:buChar char=""/>
             </a:pPr>
             <a:r>
-              <a:rPr lang="en-US" sz="2000" b="0" u="none" strike="noStrike">
-                <a:solidFill>
-                  <a:srgbClr val="000000"/>
-                </a:solidFill>
-                <a:effectLst/>
-                <a:uFillTx/>
+              <a:rPr b="0" lang="en-US" sz="2000" spc="-1" strike="noStrike">
+                <a:solidFill>
+                  <a:srgbClr val="000000"/>
+                </a:solidFill>
                 <a:latin typeface="Arial"/>
               </a:rPr>
               <a:t>Seventh Outline Level</a:t>
             </a:r>
-            <a:endParaRPr lang="en-US" sz="2000" b="0" u="none" strike="noStrike">
-              <a:solidFill>
-                <a:srgbClr val="000000"/>
-              </a:solidFill>
-              <a:effectLst/>
-              <a:uFillTx/>
-              <a:latin typeface="Arial"/>
-            </a:endParaRPr>
-          </a:p>
-        </p:txBody>
-      </p:sp>
-      <p:sp>
-        <p:nvSpPr>
-          <p:cNvPr id="4" name="PlaceHolder 3"/>
+            <a:endParaRPr b="0" lang="en-US" sz="2000" spc="-1" strike="noStrike">
+              <a:solidFill>
+                <a:srgbClr val="000000"/>
+              </a:solidFill>
+              <a:latin typeface="Arial"/>
+            </a:endParaRPr>
+          </a:p>
+        </p:txBody>
+      </p:sp>
+      <p:sp>
+        <p:nvSpPr>
+          <p:cNvPr id="2" name="PlaceHolder 3"/>
           <p:cNvSpPr>
             <a:spLocks noGrp="1"/>
           </p:cNvSpPr>
@@ -1226,43 +1003,37 @@
           </a:ln>
         </p:spPr>
         <p:txBody>
-          <a:bodyPr lIns="0" tIns="0" rIns="0" bIns="0" anchor="t">
+          <a:bodyPr lIns="0" rIns="0" tIns="0" bIns="0" anchor="t">
             <a:noAutofit/>
           </a:bodyPr>
           <a:lstStyle>
-            <a:lvl1pPr indent="0" algn="l">
+            <a:lvl1pPr indent="0">
               <a:buNone/>
-              <a:defRPr lang="en-US" sz="1400" b="0" u="none" strike="noStrike">
-                <a:solidFill>
-                  <a:srgbClr val="000000"/>
-                </a:solidFill>
-                <a:effectLst/>
-                <a:uFillTx/>
+              <a:defRPr b="0" lang="en-US" sz="1400" spc="-1" strike="noStrike">
+                <a:solidFill>
+                  <a:srgbClr val="000000"/>
+                </a:solidFill>
                 <a:latin typeface="Times New Roman"/>
               </a:defRPr>
             </a:lvl1pPr>
           </a:lstStyle>
           <a:p>
-            <a:pPr indent="0" algn="l">
+            <a:pPr indent="0">
               <a:buNone/>
             </a:pPr>
             <a:r>
-              <a:rPr lang="en-US" sz="1400" b="0" u="none" strike="noStrike">
-                <a:solidFill>
-                  <a:srgbClr val="000000"/>
-                </a:solidFill>
-                <a:effectLst/>
-                <a:uFillTx/>
+              <a:rPr b="0" lang="en-US" sz="1400" spc="-1" strike="noStrike">
+                <a:solidFill>
+                  <a:srgbClr val="000000"/>
+                </a:solidFill>
                 <a:latin typeface="Times New Roman"/>
               </a:rPr>
               <a:t>&lt;date/time&gt;</a:t>
             </a:r>
-            <a:endParaRPr lang="en-US" sz="1400" b="0" u="none" strike="noStrike">
-              <a:solidFill>
-                <a:srgbClr val="000000"/>
-              </a:solidFill>
-              <a:effectLst/>
-              <a:uFillTx/>
+            <a:endParaRPr b="0" lang="en-US" sz="1400" spc="-1" strike="noStrike">
+              <a:solidFill>
+                <a:srgbClr val="000000"/>
+              </a:solidFill>
               <a:latin typeface="Times New Roman"/>
             </a:endParaRPr>
           </a:p>
@@ -1270,7 +1041,7 @@
       </p:sp>
       <p:sp>
         <p:nvSpPr>
-          <p:cNvPr id="5" name="PlaceHolder 4"/>
+          <p:cNvPr id="3" name="PlaceHolder 4"/>
           <p:cNvSpPr>
             <a:spLocks noGrp="1"/>
           </p:cNvSpPr>
@@ -1292,18 +1063,16 @@
           </a:ln>
         </p:spPr>
         <p:txBody>
-          <a:bodyPr lIns="0" tIns="0" rIns="0" bIns="0" anchor="t">
+          <a:bodyPr lIns="0" rIns="0" tIns="0" bIns="0" anchor="t">
             <a:noAutofit/>
           </a:bodyPr>
           <a:lstStyle>
             <a:lvl1pPr indent="0" algn="ctr">
               <a:buNone/>
-              <a:defRPr lang="en-US" sz="1400" b="0" u="none" strike="noStrike">
-                <a:solidFill>
-                  <a:srgbClr val="000000"/>
-                </a:solidFill>
-                <a:effectLst/>
-                <a:uFillTx/>
+              <a:defRPr b="0" lang="en-US" sz="1400" spc="-1" strike="noStrike">
+                <a:solidFill>
+                  <a:srgbClr val="000000"/>
+                </a:solidFill>
                 <a:latin typeface="Times New Roman"/>
               </a:defRPr>
             </a:lvl1pPr>
@@ -1313,22 +1082,18 @@
               <a:buNone/>
             </a:pPr>
             <a:r>
-              <a:rPr lang="en-US" sz="1400" b="0" u="none" strike="noStrike">
-                <a:solidFill>
-                  <a:srgbClr val="000000"/>
-                </a:solidFill>
-                <a:effectLst/>
-                <a:uFillTx/>
+              <a:rPr b="0" lang="en-US" sz="1400" spc="-1" strike="noStrike">
+                <a:solidFill>
+                  <a:srgbClr val="000000"/>
+                </a:solidFill>
                 <a:latin typeface="Times New Roman"/>
               </a:rPr>
               <a:t>&lt;footer&gt;</a:t>
             </a:r>
-            <a:endParaRPr lang="en-US" sz="1400" b="0" u="none" strike="noStrike">
-              <a:solidFill>
-                <a:srgbClr val="000000"/>
-              </a:solidFill>
-              <a:effectLst/>
-              <a:uFillTx/>
+            <a:endParaRPr b="0" lang="en-US" sz="1400" spc="-1" strike="noStrike">
+              <a:solidFill>
+                <a:srgbClr val="000000"/>
+              </a:solidFill>
               <a:latin typeface="Times New Roman"/>
             </a:endParaRPr>
           </a:p>
@@ -1336,7 +1101,7 @@
       </p:sp>
       <p:sp>
         <p:nvSpPr>
-          <p:cNvPr id="6" name="PlaceHolder 5"/>
+          <p:cNvPr id="4" name="PlaceHolder 5"/>
           <p:cNvSpPr>
             <a:spLocks noGrp="1"/>
           </p:cNvSpPr>
@@ -1358,18 +1123,16 @@
           </a:ln>
         </p:spPr>
         <p:txBody>
-          <a:bodyPr lIns="0" tIns="0" rIns="0" bIns="0" anchor="t">
+          <a:bodyPr lIns="0" rIns="0" tIns="0" bIns="0" anchor="t">
             <a:noAutofit/>
           </a:bodyPr>
           <a:lstStyle>
             <a:lvl1pPr indent="0" algn="r">
               <a:buNone/>
-              <a:defRPr lang="en-US" sz="1400" b="0" u="none" strike="noStrike">
-                <a:solidFill>
-                  <a:srgbClr val="000000"/>
-                </a:solidFill>
-                <a:effectLst/>
-                <a:uFillTx/>
+              <a:defRPr b="0" lang="en-US" sz="1400" spc="-1" strike="noStrike">
+                <a:solidFill>
+                  <a:srgbClr val="000000"/>
+                </a:solidFill>
                 <a:latin typeface="Times New Roman"/>
               </a:defRPr>
             </a:lvl1pPr>
@@ -1378,23 +1141,19 @@
             <a:pPr indent="0" algn="r">
               <a:buNone/>
             </a:pPr>
-            <a:fld id="{8F588B9A-A756-4212-8C14-975D12AAA5FA}" type="slidenum">
-              <a:rPr lang="en-US" sz="1400" b="0" u="none" strike="noStrike">
-                <a:solidFill>
-                  <a:srgbClr val="000000"/>
-                </a:solidFill>
-                <a:effectLst/>
-                <a:uFillTx/>
+            <a:fld id="{39CECEF8-738A-49D9-A8E2-B1CB86401E72}" type="slidenum">
+              <a:rPr b="0" lang="en-US" sz="1400" spc="-1" strike="noStrike">
+                <a:solidFill>
+                  <a:srgbClr val="000000"/>
+                </a:solidFill>
                 <a:latin typeface="Times New Roman"/>
               </a:rPr>
               <a:t>&lt;number&gt;</a:t>
             </a:fld>
-            <a:endParaRPr lang="en-US" sz="1400" b="0" u="none" strike="noStrike">
-              <a:solidFill>
-                <a:srgbClr val="000000"/>
-              </a:solidFill>
-              <a:effectLst/>
-              <a:uFillTx/>
+            <a:endParaRPr b="0" lang="en-US" sz="1400" spc="-1" strike="noStrike">
+              <a:solidFill>
+                <a:srgbClr val="000000"/>
+              </a:solidFill>
               <a:latin typeface="Times New Roman"/>
             </a:endParaRPr>
           </a:p>
@@ -1402,7 +1161,7 @@
       </p:sp>
     </p:spTree>
   </p:cSld>
-  <p:clrMap bg1="lt1" tx1="dk1" bg2="lt2" tx2="dk2" accent1="accent1" accent2="accent2" accent3="accent3" accent4="accent4" accent5="accent5" accent6="accent6" hlink="hlink" folHlink="folHlink"/>
+  <p:clrMap bg1="lt1" bg2="lt2" tx1="dk1" tx2="dk2" accent1="accent1" accent2="accent2" accent3="accent3" accent4="accent4" accent5="accent5" accent6="accent6" hlink="hlink" folHlink="folHlink"/>
   <p:sldLayoutIdLst>
     <p:sldLayoutId id="2147483649" r:id="rId2"/>
     <p:sldLayoutId id="2147483650" r:id="rId3"/>
@@ -1429,7 +1188,7 @@
       </p:grpSpPr>
       <p:sp>
         <p:nvSpPr>
-          <p:cNvPr id="15" name="title"/>
+          <p:cNvPr id="13" name="title"/>
           <p:cNvSpPr txBox="1"/>
           <p:nvPr/>
         </p:nvSpPr>
@@ -1442,41 +1201,36 @@
             <a:avLst/>
           </a:prstGeom>
           <a:noFill/>
-          <a:ln w="38160">
+          <a:ln w="0">
             <a:noFill/>
           </a:ln>
         </p:spPr>
         <p:txBody>
-          <a:bodyPr lIns="90000" tIns="45000" rIns="90000" bIns="45000" anchor="t">
-            <a:spAutoFit/>
-          </a:bodyPr>
-          <a:p>
-            <a:pPr/>
-            <a:r>
-              <a:rPr lang="en-US" sz="3200" b="1" u="none" strike="noStrike">
-                <a:solidFill>
-                  <a:srgbClr val="000000"/>
-                </a:solidFill>
-                <a:effectLst/>
-                <a:uFillTx/>
+          <a:bodyPr lIns="90000" rIns="90000" tIns="45000" bIns="45000" anchor="t">
+            <a:noAutofit/>
+          </a:bodyPr>
+          <a:p>
+            <a:r>
+              <a:rPr b="1" lang="en-US" sz="3200" spc="-1" strike="noStrike">
+                <a:solidFill>
+                  <a:srgbClr val="000000"/>
+                </a:solidFill>
                 <a:latin typeface="Arial"/>
               </a:rPr>
               <a:t>Shoreline Survey</a:t>
             </a:r>
-            <a:endParaRPr lang="en-US" sz="3200" b="0" u="none" strike="noStrike">
-              <a:solidFill>
-                <a:srgbClr val="000000"/>
-              </a:solidFill>
-              <a:effectLst/>
-              <a:uFillTx/>
-              <a:latin typeface="Arial"/>
-            </a:endParaRPr>
-          </a:p>
-        </p:txBody>
-      </p:sp>
-      <p:sp>
-        <p:nvSpPr>
-          <p:cNvPr id="16" name="shape"/>
+            <a:endParaRPr b="0" lang="en-US" sz="3200" spc="-1" strike="noStrike">
+              <a:solidFill>
+                <a:srgbClr val="000000"/>
+              </a:solidFill>
+              <a:latin typeface="Arial"/>
+            </a:endParaRPr>
+          </a:p>
+        </p:txBody>
+      </p:sp>
+      <p:sp>
+        <p:nvSpPr>
+          <p:cNvPr id="14" name="shape"/>
           <p:cNvSpPr txBox="1"/>
           <p:nvPr/>
         </p:nvSpPr>
@@ -1489,41 +1243,32 @@
             <a:avLst/>
           </a:prstGeom>
           <a:solidFill>
-            <a:schemeClr val="accent1"/>
+            <a:srgbClr val="729fcf"/>
           </a:solidFill>
-          <a:ln w="38160">
+          <a:ln w="0">
             <a:solidFill>
-              <a:schemeClr val="accent1">
-                <a:lumMod val="75000"/>
-                <a:lumOff val="0"/>
-              </a:schemeClr>
+              <a:srgbClr val="3465a4"/>
             </a:solidFill>
-            <a:round/>
-          </a:ln>
-        </p:spPr>
-        <p:txBody>
-          <a:bodyPr lIns="90000" tIns="45000" rIns="90000" bIns="45000" anchor="t">
-            <a:spAutoFit/>
-          </a:bodyPr>
-          <a:p>
-            <a:pPr/>
-            <a:r>
-              <a:rPr lang="en-US" sz="1800" b="0" u="none" strike="noStrike">
-                <a:solidFill>
-                  <a:srgbClr val="FFFFFF"/>
-                </a:solidFill>
-                <a:effectLst/>
-                <a:uFillTx/>
+          </a:ln>
+        </p:spPr>
+        <p:txBody>
+          <a:bodyPr lIns="90000" rIns="90000" tIns="45000" bIns="45000" anchor="t">
+            <a:noAutofit/>
+          </a:bodyPr>
+          <a:p>
+            <a:r>
+              <a:rPr b="0" lang="en-US" sz="1800" spc="-1" strike="noStrike">
+                <a:solidFill>
+                  <a:srgbClr val="000000"/>
+                </a:solidFill>
                 <a:latin typeface="Arial"/>
               </a:rPr>
               <a:t>Synthetic slide content 1: Shoreline Survey.</a:t>
             </a:r>
-            <a:endParaRPr lang="en-US" sz="1800" b="0" u="none" strike="noStrike">
-              <a:solidFill>
-                <a:srgbClr val="FFFFFF"/>
-              </a:solidFill>
-              <a:effectLst/>
-              <a:uFillTx/>
+            <a:endParaRPr b="0" lang="en-US" sz="1800" spc="-1" strike="noStrike">
+              <a:solidFill>
+                <a:srgbClr val="000000"/>
+              </a:solidFill>
               <a:latin typeface="Arial"/>
             </a:endParaRPr>
           </a:p>
@@ -1561,7 +1306,7 @@
       </p:grpSpPr>
       <p:sp>
         <p:nvSpPr>
-          <p:cNvPr id="34" name="title"/>
+          <p:cNvPr id="32" name="title"/>
           <p:cNvSpPr txBox="1"/>
           <p:nvPr/>
         </p:nvSpPr>
@@ -1574,41 +1319,36 @@
             <a:avLst/>
           </a:prstGeom>
           <a:noFill/>
-          <a:ln w="38160">
+          <a:ln w="0">
             <a:noFill/>
           </a:ln>
         </p:spPr>
         <p:txBody>
-          <a:bodyPr lIns="90000" tIns="45000" rIns="90000" bIns="45000" anchor="t">
-            <a:spAutoFit/>
-          </a:bodyPr>
-          <a:p>
-            <a:pPr/>
-            <a:r>
-              <a:rPr lang="en-US" sz="3200" b="1" u="none" strike="noStrike">
-                <a:solidFill>
-                  <a:srgbClr val="000000"/>
-                </a:solidFill>
-                <a:effectLst/>
-                <a:uFillTx/>
+          <a:bodyPr lIns="90000" rIns="90000" tIns="45000" bIns="45000" anchor="t">
+            <a:noAutofit/>
+          </a:bodyPr>
+          <a:p>
+            <a:r>
+              <a:rPr b="1" lang="en-US" sz="3200" spc="-1" strike="noStrike">
+                <a:solidFill>
+                  <a:srgbClr val="000000"/>
+                </a:solidFill>
                 <a:latin typeface="Arial"/>
               </a:rPr>
               <a:t>Hidden QA Slide</a:t>
             </a:r>
-            <a:endParaRPr lang="en-US" sz="3200" b="0" u="none" strike="noStrike">
-              <a:solidFill>
-                <a:srgbClr val="000000"/>
-              </a:solidFill>
-              <a:effectLst/>
-              <a:uFillTx/>
-              <a:latin typeface="Arial"/>
-            </a:endParaRPr>
-          </a:p>
-        </p:txBody>
-      </p:sp>
-      <p:sp>
-        <p:nvSpPr>
-          <p:cNvPr id="35" name="shape"/>
+            <a:endParaRPr b="0" lang="en-US" sz="3200" spc="-1" strike="noStrike">
+              <a:solidFill>
+                <a:srgbClr val="000000"/>
+              </a:solidFill>
+              <a:latin typeface="Arial"/>
+            </a:endParaRPr>
+          </a:p>
+        </p:txBody>
+      </p:sp>
+      <p:sp>
+        <p:nvSpPr>
+          <p:cNvPr id="33" name="shape"/>
           <p:cNvSpPr txBox="1"/>
           <p:nvPr/>
         </p:nvSpPr>
@@ -1621,41 +1361,32 @@
             <a:avLst/>
           </a:prstGeom>
           <a:solidFill>
-            <a:schemeClr val="accent1"/>
+            <a:srgbClr val="729fcf"/>
           </a:solidFill>
-          <a:ln w="38160">
+          <a:ln w="0">
             <a:solidFill>
-              <a:schemeClr val="accent1">
-                <a:lumMod val="75000"/>
-                <a:lumOff val="0"/>
-              </a:schemeClr>
+              <a:srgbClr val="3465a4"/>
             </a:solidFill>
-            <a:round/>
-          </a:ln>
-        </p:spPr>
-        <p:txBody>
-          <a:bodyPr lIns="90000" tIns="45000" rIns="90000" bIns="45000" anchor="t">
-            <a:spAutoFit/>
-          </a:bodyPr>
-          <a:p>
-            <a:pPr/>
-            <a:r>
-              <a:rPr lang="en-US" sz="1800" b="0" u="none" strike="noStrike">
-                <a:solidFill>
-                  <a:srgbClr val="FFFFFF"/>
-                </a:solidFill>
-                <a:effectLst/>
-                <a:uFillTx/>
+          </a:ln>
+        </p:spPr>
+        <p:txBody>
+          <a:bodyPr lIns="90000" rIns="90000" tIns="45000" bIns="45000" anchor="t">
+            <a:noAutofit/>
+          </a:bodyPr>
+          <a:p>
+            <a:r>
+              <a:rPr b="0" lang="en-US" sz="1800" spc="-1" strike="noStrike">
+                <a:solidFill>
+                  <a:srgbClr val="000000"/>
+                </a:solidFill>
                 <a:latin typeface="Arial"/>
               </a:rPr>
               <a:t>Synthetic slide content 10: Hidden QA Slide.</a:t>
             </a:r>
-            <a:endParaRPr lang="en-US" sz="1800" b="0" u="none" strike="noStrike">
-              <a:solidFill>
-                <a:srgbClr val="FFFFFF"/>
-              </a:solidFill>
-              <a:effectLst/>
-              <a:uFillTx/>
+            <a:endParaRPr b="0" lang="en-US" sz="1800" spc="-1" strike="noStrike">
+              <a:solidFill>
+                <a:srgbClr val="000000"/>
+              </a:solidFill>
               <a:latin typeface="Arial"/>
             </a:endParaRPr>
           </a:p>
@@ -1693,7 +1424,7 @@
       </p:grpSpPr>
       <p:sp>
         <p:nvSpPr>
-          <p:cNvPr id="36" name="title"/>
+          <p:cNvPr id="34" name="title"/>
           <p:cNvSpPr txBox="1"/>
           <p:nvPr/>
         </p:nvSpPr>
@@ -1706,41 +1437,36 @@
             <a:avLst/>
           </a:prstGeom>
           <a:noFill/>
-          <a:ln w="38160">
+          <a:ln w="0">
             <a:noFill/>
           </a:ln>
         </p:spPr>
         <p:txBody>
-          <a:bodyPr lIns="90000" tIns="45000" rIns="90000" bIns="45000" anchor="t">
-            <a:spAutoFit/>
-          </a:bodyPr>
-          <a:p>
-            <a:pPr/>
-            <a:r>
-              <a:rPr lang="en-US" sz="3200" b="1" u="none" strike="noStrike">
-                <a:solidFill>
-                  <a:srgbClr val="000000"/>
-                </a:solidFill>
-                <a:effectLst/>
-                <a:uFillTx/>
+          <a:bodyPr lIns="90000" rIns="90000" tIns="45000" bIns="45000" anchor="t">
+            <a:noAutofit/>
+          </a:bodyPr>
+          <a:p>
+            <a:r>
+              <a:rPr b="1" lang="en-US" sz="3200" spc="-1" strike="noStrike">
+                <a:solidFill>
+                  <a:srgbClr val="000000"/>
+                </a:solidFill>
                 <a:latin typeface="Arial"/>
               </a:rPr>
               <a:t>Findings</a:t>
             </a:r>
-            <a:endParaRPr lang="en-US" sz="3200" b="0" u="none" strike="noStrike">
-              <a:solidFill>
-                <a:srgbClr val="000000"/>
-              </a:solidFill>
-              <a:effectLst/>
-              <a:uFillTx/>
-              <a:latin typeface="Arial"/>
-            </a:endParaRPr>
-          </a:p>
-        </p:txBody>
-      </p:sp>
-      <p:sp>
-        <p:nvSpPr>
-          <p:cNvPr id="37" name="shape"/>
+            <a:endParaRPr b="0" lang="en-US" sz="3200" spc="-1" strike="noStrike">
+              <a:solidFill>
+                <a:srgbClr val="000000"/>
+              </a:solidFill>
+              <a:latin typeface="Arial"/>
+            </a:endParaRPr>
+          </a:p>
+        </p:txBody>
+      </p:sp>
+      <p:sp>
+        <p:nvSpPr>
+          <p:cNvPr id="35" name="shape"/>
           <p:cNvSpPr txBox="1"/>
           <p:nvPr/>
         </p:nvSpPr>
@@ -1753,41 +1479,32 @@
             <a:avLst/>
           </a:prstGeom>
           <a:solidFill>
-            <a:schemeClr val="accent1"/>
+            <a:srgbClr val="729fcf"/>
           </a:solidFill>
-          <a:ln w="38160">
+          <a:ln w="0">
             <a:solidFill>
-              <a:schemeClr val="accent1">
-                <a:lumMod val="75000"/>
-                <a:lumOff val="0"/>
-              </a:schemeClr>
+              <a:srgbClr val="3465a4"/>
             </a:solidFill>
-            <a:round/>
-          </a:ln>
-        </p:spPr>
-        <p:txBody>
-          <a:bodyPr lIns="90000" tIns="45000" rIns="90000" bIns="45000" anchor="t">
-            <a:spAutoFit/>
-          </a:bodyPr>
-          <a:p>
-            <a:pPr/>
-            <a:r>
-              <a:rPr lang="en-US" sz="1800" b="0" u="none" strike="noStrike">
-                <a:solidFill>
-                  <a:srgbClr val="FFFFFF"/>
-                </a:solidFill>
-                <a:effectLst/>
-                <a:uFillTx/>
+          </a:ln>
+        </p:spPr>
+        <p:txBody>
+          <a:bodyPr lIns="90000" rIns="90000" tIns="45000" bIns="45000" anchor="t">
+            <a:noAutofit/>
+          </a:bodyPr>
+          <a:p>
+            <a:r>
+              <a:rPr b="0" lang="en-US" sz="1800" spc="-1" strike="noStrike">
+                <a:solidFill>
+                  <a:srgbClr val="000000"/>
+                </a:solidFill>
                 <a:latin typeface="Arial"/>
               </a:rPr>
               <a:t>Synthetic slide content 11: Findings.</a:t>
             </a:r>
-            <a:endParaRPr lang="en-US" sz="1800" b="0" u="none" strike="noStrike">
-              <a:solidFill>
-                <a:srgbClr val="FFFFFF"/>
-              </a:solidFill>
-              <a:effectLst/>
-              <a:uFillTx/>
+            <a:endParaRPr b="0" lang="en-US" sz="1800" spc="-1" strike="noStrike">
+              <a:solidFill>
+                <a:srgbClr val="000000"/>
+              </a:solidFill>
               <a:latin typeface="Arial"/>
             </a:endParaRPr>
           </a:p>
@@ -1825,7 +1542,7 @@
       </p:grpSpPr>
       <p:sp>
         <p:nvSpPr>
-          <p:cNvPr id="38" name="title"/>
+          <p:cNvPr id="36" name="title"/>
           <p:cNvSpPr txBox="1"/>
           <p:nvPr/>
         </p:nvSpPr>
@@ -1838,41 +1555,36 @@
             <a:avLst/>
           </a:prstGeom>
           <a:noFill/>
-          <a:ln w="38160">
+          <a:ln w="0">
             <a:noFill/>
           </a:ln>
         </p:spPr>
         <p:txBody>
-          <a:bodyPr lIns="90000" tIns="45000" rIns="90000" bIns="45000" anchor="t">
-            <a:spAutoFit/>
-          </a:bodyPr>
-          <a:p>
-            <a:pPr/>
-            <a:r>
-              <a:rPr lang="en-US" sz="3200" b="1" u="none" strike="noStrike">
-                <a:solidFill>
-                  <a:srgbClr val="000000"/>
-                </a:solidFill>
-                <a:effectLst/>
-                <a:uFillTx/>
+          <a:bodyPr lIns="90000" rIns="90000" tIns="45000" bIns="45000" anchor="t">
+            <a:noAutofit/>
+          </a:bodyPr>
+          <a:p>
+            <a:r>
+              <a:rPr b="1" lang="en-US" sz="3200" spc="-1" strike="noStrike">
+                <a:solidFill>
+                  <a:srgbClr val="000000"/>
+                </a:solidFill>
                 <a:latin typeface="Arial"/>
               </a:rPr>
               <a:t>Next Steps</a:t>
             </a:r>
-            <a:endParaRPr lang="en-US" sz="3200" b="0" u="none" strike="noStrike">
-              <a:solidFill>
-                <a:srgbClr val="000000"/>
-              </a:solidFill>
-              <a:effectLst/>
-              <a:uFillTx/>
-              <a:latin typeface="Arial"/>
-            </a:endParaRPr>
-          </a:p>
-        </p:txBody>
-      </p:sp>
-      <p:sp>
-        <p:nvSpPr>
-          <p:cNvPr id="39" name="shape"/>
+            <a:endParaRPr b="0" lang="en-US" sz="3200" spc="-1" strike="noStrike">
+              <a:solidFill>
+                <a:srgbClr val="000000"/>
+              </a:solidFill>
+              <a:latin typeface="Arial"/>
+            </a:endParaRPr>
+          </a:p>
+        </p:txBody>
+      </p:sp>
+      <p:sp>
+        <p:nvSpPr>
+          <p:cNvPr id="37" name="shape"/>
           <p:cNvSpPr txBox="1"/>
           <p:nvPr/>
         </p:nvSpPr>
@@ -1885,41 +1597,32 @@
             <a:avLst/>
           </a:prstGeom>
           <a:solidFill>
-            <a:schemeClr val="accent1"/>
+            <a:srgbClr val="729fcf"/>
           </a:solidFill>
-          <a:ln w="38160">
+          <a:ln w="0">
             <a:solidFill>
-              <a:schemeClr val="accent1">
-                <a:lumMod val="75000"/>
-                <a:lumOff val="0"/>
-              </a:schemeClr>
+              <a:srgbClr val="3465a4"/>
             </a:solidFill>
-            <a:round/>
-          </a:ln>
-        </p:spPr>
-        <p:txBody>
-          <a:bodyPr lIns="90000" tIns="45000" rIns="90000" bIns="45000" anchor="t">
-            <a:spAutoFit/>
-          </a:bodyPr>
-          <a:p>
-            <a:pPr/>
-            <a:r>
-              <a:rPr lang="en-US" sz="1800" b="0" u="none" strike="noStrike">
-                <a:solidFill>
-                  <a:srgbClr val="FFFFFF"/>
-                </a:solidFill>
-                <a:effectLst/>
-                <a:uFillTx/>
+          </a:ln>
+        </p:spPr>
+        <p:txBody>
+          <a:bodyPr lIns="90000" rIns="90000" tIns="45000" bIns="45000" anchor="t">
+            <a:noAutofit/>
+          </a:bodyPr>
+          <a:p>
+            <a:r>
+              <a:rPr b="0" lang="en-US" sz="1800" spc="-1" strike="noStrike">
+                <a:solidFill>
+                  <a:srgbClr val="000000"/>
+                </a:solidFill>
                 <a:latin typeface="Arial"/>
               </a:rPr>
               <a:t>Synthetic slide content 12: Next Steps.</a:t>
             </a:r>
-            <a:endParaRPr lang="en-US" sz="1800" b="0" u="none" strike="noStrike">
-              <a:solidFill>
-                <a:srgbClr val="FFFFFF"/>
-              </a:solidFill>
-              <a:effectLst/>
-              <a:uFillTx/>
+            <a:endParaRPr b="0" lang="en-US" sz="1800" spc="-1" strike="noStrike">
+              <a:solidFill>
+                <a:srgbClr val="000000"/>
+              </a:solidFill>
               <a:latin typeface="Arial"/>
             </a:endParaRPr>
           </a:p>
@@ -1957,7 +1660,7 @@
       </p:grpSpPr>
       <p:sp>
         <p:nvSpPr>
-          <p:cNvPr id="17" name="title"/>
+          <p:cNvPr id="15" name="title"/>
           <p:cNvSpPr txBox="1"/>
           <p:nvPr/>
         </p:nvSpPr>
@@ -1970,41 +1673,36 @@
             <a:avLst/>
           </a:prstGeom>
           <a:noFill/>
-          <a:ln w="38160">
+          <a:ln w="0">
             <a:noFill/>
           </a:ln>
         </p:spPr>
         <p:txBody>
-          <a:bodyPr lIns="90000" tIns="45000" rIns="90000" bIns="45000" anchor="t">
-            <a:spAutoFit/>
-          </a:bodyPr>
-          <a:p>
-            <a:pPr/>
-            <a:r>
-              <a:rPr lang="en-US" sz="3200" b="1" u="none" strike="noStrike">
-                <a:solidFill>
-                  <a:srgbClr val="000000"/>
-                </a:solidFill>
-                <a:effectLst/>
-                <a:uFillTx/>
+          <a:bodyPr lIns="90000" rIns="90000" tIns="45000" bIns="45000" anchor="t">
+            <a:noAutofit/>
+          </a:bodyPr>
+          <a:p>
+            <a:r>
+              <a:rPr b="1" lang="en-US" sz="3200" spc="-1" strike="noStrike">
+                <a:solidFill>
+                  <a:srgbClr val="000000"/>
+                </a:solidFill>
                 <a:latin typeface="Arial"/>
               </a:rPr>
               <a:t>Purpose and Scope</a:t>
             </a:r>
-            <a:endParaRPr lang="en-US" sz="3200" b="0" u="none" strike="noStrike">
-              <a:solidFill>
-                <a:srgbClr val="000000"/>
-              </a:solidFill>
-              <a:effectLst/>
-              <a:uFillTx/>
-              <a:latin typeface="Arial"/>
-            </a:endParaRPr>
-          </a:p>
-        </p:txBody>
-      </p:sp>
-      <p:sp>
-        <p:nvSpPr>
-          <p:cNvPr id="18" name="shape"/>
+            <a:endParaRPr b="0" lang="en-US" sz="3200" spc="-1" strike="noStrike">
+              <a:solidFill>
+                <a:srgbClr val="000000"/>
+              </a:solidFill>
+              <a:latin typeface="Arial"/>
+            </a:endParaRPr>
+          </a:p>
+        </p:txBody>
+      </p:sp>
+      <p:sp>
+        <p:nvSpPr>
+          <p:cNvPr id="16" name="shape"/>
           <p:cNvSpPr txBox="1"/>
           <p:nvPr/>
         </p:nvSpPr>
@@ -2017,41 +1715,32 @@
             <a:avLst/>
           </a:prstGeom>
           <a:solidFill>
-            <a:schemeClr val="accent1"/>
+            <a:srgbClr val="729fcf"/>
           </a:solidFill>
-          <a:ln w="38160">
+          <a:ln w="0">
             <a:solidFill>
-              <a:schemeClr val="accent1">
-                <a:lumMod val="75000"/>
-                <a:lumOff val="0"/>
-              </a:schemeClr>
+              <a:srgbClr val="3465a4"/>
             </a:solidFill>
-            <a:round/>
-          </a:ln>
-        </p:spPr>
-        <p:txBody>
-          <a:bodyPr lIns="90000" tIns="45000" rIns="90000" bIns="45000" anchor="t">
-            <a:spAutoFit/>
-          </a:bodyPr>
-          <a:p>
-            <a:pPr/>
-            <a:r>
-              <a:rPr lang="en-US" sz="1800" b="0" u="none" strike="noStrike">
-                <a:solidFill>
-                  <a:srgbClr val="FFFFFF"/>
-                </a:solidFill>
-                <a:effectLst/>
-                <a:uFillTx/>
+          </a:ln>
+        </p:spPr>
+        <p:txBody>
+          <a:bodyPr lIns="90000" rIns="90000" tIns="45000" bIns="45000" anchor="t">
+            <a:noAutofit/>
+          </a:bodyPr>
+          <a:p>
+            <a:r>
+              <a:rPr b="0" lang="en-US" sz="1800" spc="-1" strike="noStrike">
+                <a:solidFill>
+                  <a:srgbClr val="000000"/>
+                </a:solidFill>
                 <a:latin typeface="Arial"/>
               </a:rPr>
               <a:t>Synthetic slide content 2: Purpose and Scope.</a:t>
             </a:r>
-            <a:endParaRPr lang="en-US" sz="1800" b="0" u="none" strike="noStrike">
-              <a:solidFill>
-                <a:srgbClr val="FFFFFF"/>
-              </a:solidFill>
-              <a:effectLst/>
-              <a:uFillTx/>
+            <a:endParaRPr b="0" lang="en-US" sz="1800" spc="-1" strike="noStrike">
+              <a:solidFill>
+                <a:srgbClr val="000000"/>
+              </a:solidFill>
               <a:latin typeface="Arial"/>
             </a:endParaRPr>
           </a:p>
@@ -2089,7 +1778,7 @@
       </p:grpSpPr>
       <p:sp>
         <p:nvSpPr>
-          <p:cNvPr id="19" name="title"/>
+          <p:cNvPr id="17" name="title"/>
           <p:cNvSpPr txBox="1"/>
           <p:nvPr/>
         </p:nvSpPr>
@@ -2102,41 +1791,36 @@
             <a:avLst/>
           </a:prstGeom>
           <a:noFill/>
-          <a:ln w="38160">
+          <a:ln w="0">
             <a:noFill/>
           </a:ln>
         </p:spPr>
         <p:txBody>
-          <a:bodyPr lIns="90000" tIns="45000" rIns="90000" bIns="45000" anchor="t">
-            <a:spAutoFit/>
-          </a:bodyPr>
-          <a:p>
-            <a:pPr/>
-            <a:r>
-              <a:rPr lang="en-US" sz="3200" b="1" u="none" strike="noStrike">
-                <a:solidFill>
-                  <a:srgbClr val="000000"/>
-                </a:solidFill>
-                <a:effectLst/>
-                <a:uFillTx/>
+          <a:bodyPr lIns="90000" rIns="90000" tIns="45000" bIns="45000" anchor="t">
+            <a:noAutofit/>
+          </a:bodyPr>
+          <a:p>
+            <a:r>
+              <a:rPr b="1" lang="en-US" sz="3200" spc="-1" strike="noStrike">
+                <a:solidFill>
+                  <a:srgbClr val="000000"/>
+                </a:solidFill>
                 <a:latin typeface="Arial"/>
               </a:rPr>
               <a:t>Sites</a:t>
             </a:r>
-            <a:endParaRPr lang="en-US" sz="3200" b="0" u="none" strike="noStrike">
-              <a:solidFill>
-                <a:srgbClr val="000000"/>
-              </a:solidFill>
-              <a:effectLst/>
-              <a:uFillTx/>
-              <a:latin typeface="Arial"/>
-            </a:endParaRPr>
-          </a:p>
-        </p:txBody>
-      </p:sp>
-      <p:sp>
-        <p:nvSpPr>
-          <p:cNvPr id="20" name="shape"/>
+            <a:endParaRPr b="0" lang="en-US" sz="3200" spc="-1" strike="noStrike">
+              <a:solidFill>
+                <a:srgbClr val="000000"/>
+              </a:solidFill>
+              <a:latin typeface="Arial"/>
+            </a:endParaRPr>
+          </a:p>
+        </p:txBody>
+      </p:sp>
+      <p:sp>
+        <p:nvSpPr>
+          <p:cNvPr id="18" name="shape"/>
           <p:cNvSpPr txBox="1"/>
           <p:nvPr/>
         </p:nvSpPr>
@@ -2149,41 +1833,32 @@
             <a:avLst/>
           </a:prstGeom>
           <a:solidFill>
-            <a:schemeClr val="accent1"/>
+            <a:srgbClr val="729fcf"/>
           </a:solidFill>
-          <a:ln w="38160">
+          <a:ln w="0">
             <a:solidFill>
-              <a:schemeClr val="accent1">
-                <a:lumMod val="75000"/>
-                <a:lumOff val="0"/>
-              </a:schemeClr>
+              <a:srgbClr val="3465a4"/>
             </a:solidFill>
-            <a:round/>
-          </a:ln>
-        </p:spPr>
-        <p:txBody>
-          <a:bodyPr lIns="90000" tIns="45000" rIns="90000" bIns="45000" anchor="t">
-            <a:spAutoFit/>
-          </a:bodyPr>
-          <a:p>
-            <a:pPr/>
-            <a:r>
-              <a:rPr lang="en-US" sz="1800" b="0" u="none" strike="noStrike">
-                <a:solidFill>
-                  <a:srgbClr val="FFFFFF"/>
-                </a:solidFill>
-                <a:effectLst/>
-                <a:uFillTx/>
+          </a:ln>
+        </p:spPr>
+        <p:txBody>
+          <a:bodyPr lIns="90000" rIns="90000" tIns="45000" bIns="45000" anchor="t">
+            <a:noAutofit/>
+          </a:bodyPr>
+          <a:p>
+            <a:r>
+              <a:rPr b="0" lang="en-US" sz="1800" spc="-1" strike="noStrike">
+                <a:solidFill>
+                  <a:srgbClr val="000000"/>
+                </a:solidFill>
                 <a:latin typeface="Arial"/>
               </a:rPr>
               <a:t>Synthetic slide content 3: Sites.</a:t>
             </a:r>
-            <a:endParaRPr lang="en-US" sz="1800" b="0" u="none" strike="noStrike">
-              <a:solidFill>
-                <a:srgbClr val="FFFFFF"/>
-              </a:solidFill>
-              <a:effectLst/>
-              <a:uFillTx/>
+            <a:endParaRPr b="0" lang="en-US" sz="1800" spc="-1" strike="noStrike">
+              <a:solidFill>
+                <a:srgbClr val="000000"/>
+              </a:solidFill>
               <a:latin typeface="Arial"/>
             </a:endParaRPr>
           </a:p>
@@ -2221,7 +1896,7 @@
       </p:grpSpPr>
       <p:sp>
         <p:nvSpPr>
-          <p:cNvPr id="21" name="title"/>
+          <p:cNvPr id="19" name="title"/>
           <p:cNvSpPr txBox="1"/>
           <p:nvPr/>
         </p:nvSpPr>
@@ -2234,33 +1909,28 @@
             <a:avLst/>
           </a:prstGeom>
           <a:noFill/>
-          <a:ln w="38160">
+          <a:ln w="0">
             <a:noFill/>
           </a:ln>
         </p:spPr>
         <p:txBody>
-          <a:bodyPr lIns="90000" tIns="45000" rIns="90000" bIns="45000" anchor="t">
-            <a:spAutoFit/>
-          </a:bodyPr>
-          <a:p>
-            <a:pPr/>
-            <a:r>
-              <a:rPr lang="en-US" sz="3200" b="1" u="none" strike="noStrike">
-                <a:solidFill>
-                  <a:srgbClr val="000000"/>
-                </a:solidFill>
-                <a:effectLst/>
-                <a:uFillTx/>
+          <a:bodyPr lIns="90000" rIns="90000" tIns="45000" bIns="45000" anchor="t">
+            <a:noAutofit/>
+          </a:bodyPr>
+          <a:p>
+            <a:r>
+              <a:rPr b="1" lang="en-US" sz="3200" spc="-1" strike="noStrike">
+                <a:solidFill>
+                  <a:srgbClr val="000000"/>
+                </a:solidFill>
                 <a:latin typeface="Arial"/>
               </a:rPr>
               <a:t>Sampling Groups</a:t>
             </a:r>
-            <a:endParaRPr lang="en-US" sz="3200" b="0" u="none" strike="noStrike">
-              <a:solidFill>
-                <a:srgbClr val="000000"/>
-              </a:solidFill>
-              <a:effectLst/>
-              <a:uFillTx/>
+            <a:endParaRPr b="0" lang="en-US" sz="3200" spc="-1" strike="noStrike">
+              <a:solidFill>
+                <a:srgbClr val="000000"/>
+              </a:solidFill>
               <a:latin typeface="Arial"/>
             </a:endParaRPr>
           </a:p>
@@ -2268,7 +1938,7 @@
       </p:sp>
       <p:grpSp>
         <p:nvGrpSpPr>
-          <p:cNvPr id="22" name="Sampling team group"/>
+          <p:cNvPr id="20" name="Sampling team group"/>
           <p:cNvGrpSpPr/>
           <p:nvPr/>
         </p:nvGrpSpPr>
@@ -2282,7 +1952,7 @@
         </p:grpSpPr>
         <p:sp>
           <p:nvSpPr>
-            <p:cNvPr id="23" name="shape"/>
+            <p:cNvPr id="21" name="shape"/>
             <p:cNvSpPr txBox="1"/>
             <p:nvPr/>
           </p:nvSpPr>
@@ -2295,41 +1965,32 @@
               <a:avLst/>
             </a:prstGeom>
             <a:solidFill>
-              <a:schemeClr val="accent1"/>
+              <a:srgbClr val="729fcf"/>
             </a:solidFill>
-            <a:ln w="38160">
-              <a:solidFill>
-                <a:schemeClr val="accent1">
-                  <a:lumMod val="75000"/>
-                  <a:lumOff val="0"/>
-                </a:schemeClr>
-              </a:solidFill>
-              <a:round/>
+            <a:ln w="0">
+              <a:solidFill>
+                <a:srgbClr val="3465a4"/>
+              </a:solidFill>
             </a:ln>
           </p:spPr>
           <p:txBody>
-            <a:bodyPr lIns="90000" tIns="45000" rIns="90000" bIns="45000" anchor="t">
-              <a:spAutoFit/>
+            <a:bodyPr lIns="90000" rIns="90000" tIns="45000" bIns="45000" anchor="t">
+              <a:noAutofit/>
             </a:bodyPr>
             <a:p>
-              <a:pPr/>
               <a:r>
-                <a:rPr lang="en-US" sz="1800" b="0" u="none" strike="noStrike">
+                <a:rPr b="0" lang="en-US" sz="1800" spc="-1" strike="noStrike">
                   <a:solidFill>
-                    <a:srgbClr val="FFFFFF"/>
+                    <a:srgbClr val="000000"/>
                   </a:solidFill>
-                  <a:effectLst/>
-                  <a:uFillTx/>
                   <a:latin typeface="Arial"/>
                 </a:rPr>
                 <a:t>Group member: North crew</a:t>
               </a:r>
-              <a:endParaRPr lang="en-US" sz="1800" b="0" u="none" strike="noStrike">
-                <a:solidFill>
-                  <a:srgbClr val="FFFFFF"/>
-                </a:solidFill>
-                <a:effectLst/>
-                <a:uFillTx/>
+              <a:endParaRPr b="0" lang="en-US" sz="1800" spc="-1" strike="noStrike">
+                <a:solidFill>
+                  <a:srgbClr val="000000"/>
+                </a:solidFill>
                 <a:latin typeface="Arial"/>
               </a:endParaRPr>
             </a:p>
@@ -2337,7 +1998,7 @@
         </p:sp>
         <p:sp>
           <p:nvSpPr>
-            <p:cNvPr id="24" name="shape"/>
+            <p:cNvPr id="22" name="shape"/>
             <p:cNvSpPr txBox="1"/>
             <p:nvPr/>
           </p:nvSpPr>
@@ -2350,41 +2011,32 @@
               <a:avLst/>
             </a:prstGeom>
             <a:solidFill>
-              <a:schemeClr val="accent1"/>
+              <a:srgbClr val="729fcf"/>
             </a:solidFill>
-            <a:ln w="38160">
-              <a:solidFill>
-                <a:schemeClr val="accent1">
-                  <a:lumMod val="75000"/>
-                  <a:lumOff val="0"/>
-                </a:schemeClr>
-              </a:solidFill>
-              <a:round/>
+            <a:ln w="0">
+              <a:solidFill>
+                <a:srgbClr val="3465a4"/>
+              </a:solidFill>
             </a:ln>
           </p:spPr>
           <p:txBody>
-            <a:bodyPr lIns="90000" tIns="45000" rIns="90000" bIns="45000" anchor="t">
-              <a:spAutoFit/>
+            <a:bodyPr lIns="90000" rIns="90000" tIns="45000" bIns="45000" anchor="t">
+              <a:noAutofit/>
             </a:bodyPr>
             <a:p>
-              <a:pPr/>
               <a:r>
-                <a:rPr lang="en-US" sz="1800" b="0" u="none" strike="noStrike">
+                <a:rPr b="0" lang="en-US" sz="1800" spc="-1" strike="noStrike">
                   <a:solidFill>
-                    <a:srgbClr val="FFFFFF"/>
+                    <a:srgbClr val="000000"/>
                   </a:solidFill>
-                  <a:effectLst/>
-                  <a:uFillTx/>
                   <a:latin typeface="Arial"/>
                 </a:rPr>
                 <a:t>Group member: South crew</a:t>
               </a:r>
-              <a:endParaRPr lang="en-US" sz="1800" b="0" u="none" strike="noStrike">
-                <a:solidFill>
-                  <a:srgbClr val="FFFFFF"/>
-                </a:solidFill>
-                <a:effectLst/>
-                <a:uFillTx/>
+              <a:endParaRPr b="0" lang="en-US" sz="1800" spc="-1" strike="noStrike">
+                <a:solidFill>
+                  <a:srgbClr val="000000"/>
+                </a:solidFill>
                 <a:latin typeface="Arial"/>
               </a:endParaRPr>
             </a:p>
@@ -2423,7 +2075,7 @@
       </p:grpSpPr>
       <p:sp>
         <p:nvSpPr>
-          <p:cNvPr id="25" name="title"/>
+          <p:cNvPr id="23" name="title"/>
           <p:cNvSpPr txBox="1"/>
           <p:nvPr/>
         </p:nvSpPr>
@@ -2436,41 +2088,36 @@
             <a:avLst/>
           </a:prstGeom>
           <a:noFill/>
-          <a:ln w="38160">
+          <a:ln w="0">
             <a:noFill/>
           </a:ln>
         </p:spPr>
         <p:txBody>
-          <a:bodyPr lIns="90000" tIns="45000" rIns="90000" bIns="45000" anchor="t">
-            <a:spAutoFit/>
-          </a:bodyPr>
-          <a:p>
-            <a:pPr/>
-            <a:r>
-              <a:rPr lang="en-US" sz="3200" b="1" u="none" strike="noStrike">
-                <a:solidFill>
-                  <a:srgbClr val="000000"/>
-                </a:solidFill>
-                <a:effectLst/>
-                <a:uFillTx/>
+          <a:bodyPr lIns="90000" rIns="90000" tIns="45000" bIns="45000" anchor="t">
+            <a:noAutofit/>
+          </a:bodyPr>
+          <a:p>
+            <a:r>
+              <a:rPr b="1" lang="en-US" sz="3200" spc="-1" strike="noStrike">
+                <a:solidFill>
+                  <a:srgbClr val="000000"/>
+                </a:solidFill>
                 <a:latin typeface="Arial"/>
               </a:rPr>
               <a:t>Tools</a:t>
             </a:r>
-            <a:endParaRPr lang="en-US" sz="3200" b="0" u="none" strike="noStrike">
-              <a:solidFill>
-                <a:srgbClr val="000000"/>
-              </a:solidFill>
-              <a:effectLst/>
-              <a:uFillTx/>
-              <a:latin typeface="Arial"/>
-            </a:endParaRPr>
-          </a:p>
-        </p:txBody>
-      </p:sp>
-      <p:sp>
-        <p:nvSpPr>
-          <p:cNvPr id="26" name="shape"/>
+            <a:endParaRPr b="0" lang="en-US" sz="3200" spc="-1" strike="noStrike">
+              <a:solidFill>
+                <a:srgbClr val="000000"/>
+              </a:solidFill>
+              <a:latin typeface="Arial"/>
+            </a:endParaRPr>
+          </a:p>
+        </p:txBody>
+      </p:sp>
+      <p:sp>
+        <p:nvSpPr>
+          <p:cNvPr id="24" name="shape"/>
           <p:cNvSpPr txBox="1"/>
           <p:nvPr/>
         </p:nvSpPr>
@@ -2483,41 +2130,32 @@
             <a:avLst/>
           </a:prstGeom>
           <a:solidFill>
-            <a:schemeClr val="accent1"/>
+            <a:srgbClr val="729fcf"/>
           </a:solidFill>
-          <a:ln w="38160">
+          <a:ln w="0">
             <a:solidFill>
-              <a:schemeClr val="accent1">
-                <a:lumMod val="75000"/>
-                <a:lumOff val="0"/>
-              </a:schemeClr>
+              <a:srgbClr val="3465a4"/>
             </a:solidFill>
-            <a:round/>
-          </a:ln>
-        </p:spPr>
-        <p:txBody>
-          <a:bodyPr lIns="90000" tIns="45000" rIns="90000" bIns="45000" anchor="t">
-            <a:spAutoFit/>
-          </a:bodyPr>
-          <a:p>
-            <a:pPr/>
-            <a:r>
-              <a:rPr lang="en-US" sz="1800" b="0" u="none" strike="noStrike">
-                <a:solidFill>
-                  <a:srgbClr val="FFFFFF"/>
-                </a:solidFill>
-                <a:effectLst/>
-                <a:uFillTx/>
+          </a:ln>
+        </p:spPr>
+        <p:txBody>
+          <a:bodyPr lIns="90000" rIns="90000" tIns="45000" bIns="45000" anchor="t">
+            <a:noAutofit/>
+          </a:bodyPr>
+          <a:p>
+            <a:r>
+              <a:rPr b="0" lang="en-US" sz="1800" spc="-1" strike="noStrike">
+                <a:solidFill>
+                  <a:srgbClr val="000000"/>
+                </a:solidFill>
                 <a:latin typeface="Arial"/>
               </a:rPr>
               <a:t>Synthetic slide content 5: Tools.</a:t>
             </a:r>
-            <a:endParaRPr lang="en-US" sz="1800" b="0" u="none" strike="noStrike">
-              <a:solidFill>
-                <a:srgbClr val="FFFFFF"/>
-              </a:solidFill>
-              <a:effectLst/>
-              <a:uFillTx/>
+            <a:endParaRPr b="0" lang="en-US" sz="1800" spc="-1" strike="noStrike">
+              <a:solidFill>
+                <a:srgbClr val="000000"/>
+              </a:solidFill>
               <a:latin typeface="Arial"/>
             </a:endParaRPr>
           </a:p>
@@ -2555,7 +2193,7 @@
       </p:grpSpPr>
       <p:sp>
         <p:nvSpPr>
-          <p:cNvPr id="27" name="title"/>
+          <p:cNvPr id="25" name="title"/>
           <p:cNvSpPr txBox="1"/>
           <p:nvPr/>
         </p:nvSpPr>
@@ -2568,41 +2206,36 @@
             <a:avLst/>
           </a:prstGeom>
           <a:noFill/>
-          <a:ln w="38160">
+          <a:ln w="0">
             <a:noFill/>
           </a:ln>
         </p:spPr>
         <p:txBody>
-          <a:bodyPr lIns="90000" tIns="45000" rIns="90000" bIns="45000" anchor="t">
-            <a:spAutoFit/>
-          </a:bodyPr>
-          <a:p>
-            <a:pPr/>
-            <a:r>
-              <a:rPr lang="en-US" sz="3200" b="1" u="none" strike="noStrike">
-                <a:solidFill>
-                  <a:srgbClr val="000000"/>
-                </a:solidFill>
-                <a:effectLst/>
-                <a:uFillTx/>
+          <a:bodyPr lIns="90000" rIns="90000" tIns="45000" bIns="45000" anchor="t">
+            <a:noAutofit/>
+          </a:bodyPr>
+          <a:p>
+            <a:r>
+              <a:rPr b="1" lang="en-US" sz="3200" spc="-1" strike="noStrike">
+                <a:solidFill>
+                  <a:srgbClr val="000000"/>
+                </a:solidFill>
                 <a:latin typeface="Arial"/>
               </a:rPr>
               <a:t>Daily Sequence</a:t>
             </a:r>
-            <a:endParaRPr lang="en-US" sz="3200" b="0" u="none" strike="noStrike">
-              <a:solidFill>
-                <a:srgbClr val="000000"/>
-              </a:solidFill>
-              <a:effectLst/>
-              <a:uFillTx/>
-              <a:latin typeface="Arial"/>
-            </a:endParaRPr>
-          </a:p>
-        </p:txBody>
-      </p:sp>
-      <p:sp>
-        <p:nvSpPr>
-          <p:cNvPr id="28" name="shape"/>
+            <a:endParaRPr b="0" lang="en-US" sz="3200" spc="-1" strike="noStrike">
+              <a:solidFill>
+                <a:srgbClr val="000000"/>
+              </a:solidFill>
+              <a:latin typeface="Arial"/>
+            </a:endParaRPr>
+          </a:p>
+        </p:txBody>
+      </p:sp>
+      <p:sp>
+        <p:nvSpPr>
+          <p:cNvPr id="26" name="shape"/>
           <p:cNvSpPr txBox="1"/>
           <p:nvPr/>
         </p:nvSpPr>
@@ -2615,41 +2248,32 @@
             <a:avLst/>
           </a:prstGeom>
           <a:solidFill>
-            <a:schemeClr val="accent1"/>
+            <a:srgbClr val="729fcf"/>
           </a:solidFill>
-          <a:ln w="38160">
+          <a:ln w="0">
             <a:solidFill>
-              <a:schemeClr val="accent1">
-                <a:lumMod val="75000"/>
-                <a:lumOff val="0"/>
-              </a:schemeClr>
+              <a:srgbClr val="3465a4"/>
             </a:solidFill>
-            <a:round/>
-          </a:ln>
-        </p:spPr>
-        <p:txBody>
-          <a:bodyPr lIns="90000" tIns="45000" rIns="90000" bIns="45000" anchor="t">
-            <a:spAutoFit/>
-          </a:bodyPr>
-          <a:p>
-            <a:pPr/>
-            <a:r>
-              <a:rPr lang="en-US" sz="1800" b="0" u="none" strike="noStrike">
-                <a:solidFill>
-                  <a:srgbClr val="FFFFFF"/>
-                </a:solidFill>
-                <a:effectLst/>
-                <a:uFillTx/>
+          </a:ln>
+        </p:spPr>
+        <p:txBody>
+          <a:bodyPr lIns="90000" rIns="90000" tIns="45000" bIns="45000" anchor="t">
+            <a:noAutofit/>
+          </a:bodyPr>
+          <a:p>
+            <a:r>
+              <a:rPr b="0" lang="en-US" sz="1800" spc="-1" strike="noStrike">
+                <a:solidFill>
+                  <a:srgbClr val="000000"/>
+                </a:solidFill>
                 <a:latin typeface="Arial"/>
               </a:rPr>
               <a:t>Synthetic slide content 6: Daily Sequence.</a:t>
             </a:r>
-            <a:endParaRPr lang="en-US" sz="1800" b="0" u="none" strike="noStrike">
-              <a:solidFill>
-                <a:srgbClr val="FFFFFF"/>
-              </a:solidFill>
-              <a:effectLst/>
-              <a:uFillTx/>
+            <a:endParaRPr b="0" lang="en-US" sz="1800" spc="-1" strike="noStrike">
+              <a:solidFill>
+                <a:srgbClr val="000000"/>
+              </a:solidFill>
               <a:latin typeface="Arial"/>
             </a:endParaRPr>
           </a:p>
@@ -2687,7 +2311,7 @@
       </p:grpSpPr>
       <p:sp>
         <p:nvSpPr>
-          <p:cNvPr id="29" name="title"/>
+          <p:cNvPr id="27" name="title"/>
           <p:cNvSpPr txBox="1"/>
           <p:nvPr/>
         </p:nvSpPr>
@@ -2700,33 +2324,28 @@
             <a:avLst/>
           </a:prstGeom>
           <a:noFill/>
-          <a:ln w="38160">
+          <a:ln w="0">
             <a:noFill/>
           </a:ln>
         </p:spPr>
         <p:txBody>
-          <a:bodyPr lIns="90000" tIns="45000" rIns="90000" bIns="45000" anchor="t">
-            <a:spAutoFit/>
-          </a:bodyPr>
-          <a:p>
-            <a:pPr/>
-            <a:r>
-              <a:rPr lang="en-US" sz="3200" b="1" u="none" strike="noStrike">
-                <a:solidFill>
-                  <a:srgbClr val="000000"/>
-                </a:solidFill>
-                <a:effectLst/>
-                <a:uFillTx/>
+          <a:bodyPr lIns="90000" rIns="90000" tIns="45000" bIns="45000" anchor="t">
+            <a:noAutofit/>
+          </a:bodyPr>
+          <a:p>
+            <a:r>
+              <a:rPr b="1" lang="en-US" sz="3200" spc="-1" strike="noStrike">
+                <a:solidFill>
+                  <a:srgbClr val="000000"/>
+                </a:solidFill>
                 <a:latin typeface="Arial"/>
               </a:rPr>
               <a:t>Observation Table</a:t>
             </a:r>
-            <a:endParaRPr lang="en-US" sz="3200" b="0" u="none" strike="noStrike">
-              <a:solidFill>
-                <a:srgbClr val="000000"/>
-              </a:solidFill>
-              <a:effectLst/>
-              <a:uFillTx/>
+            <a:endParaRPr b="0" lang="en-US" sz="3200" spc="-1" strike="noStrike">
+              <a:solidFill>
+                <a:srgbClr val="000000"/>
+              </a:solidFill>
               <a:latin typeface="Arial"/>
             </a:endParaRPr>
           </a:p>
@@ -2764,7 +2383,7 @@
       </p:grpSpPr>
       <p:sp>
         <p:nvSpPr>
-          <p:cNvPr id="30" name="title"/>
+          <p:cNvPr id="28" name="title"/>
           <p:cNvSpPr txBox="1"/>
           <p:nvPr/>
         </p:nvSpPr>
@@ -2777,41 +2396,36 @@
             <a:avLst/>
           </a:prstGeom>
           <a:noFill/>
-          <a:ln w="38160">
+          <a:ln w="0">
             <a:noFill/>
           </a:ln>
         </p:spPr>
         <p:txBody>
-          <a:bodyPr lIns="90000" tIns="45000" rIns="90000" bIns="45000" anchor="t">
-            <a:spAutoFit/>
-          </a:bodyPr>
-          <a:p>
-            <a:pPr/>
-            <a:r>
-              <a:rPr lang="en-US" sz="3200" b="1" u="none" strike="noStrike">
-                <a:solidFill>
-                  <a:srgbClr val="000000"/>
-                </a:solidFill>
-                <a:effectLst/>
-                <a:uFillTx/>
+          <a:bodyPr lIns="90000" rIns="90000" tIns="45000" bIns="45000" anchor="t">
+            <a:noAutofit/>
+          </a:bodyPr>
+          <a:p>
+            <a:r>
+              <a:rPr b="1" lang="en-US" sz="3200" spc="-1" strike="noStrike">
+                <a:solidFill>
+                  <a:srgbClr val="000000"/>
+                </a:solidFill>
                 <a:latin typeface="Arial"/>
               </a:rPr>
               <a:t>Quality Checks</a:t>
             </a:r>
-            <a:endParaRPr lang="en-US" sz="3200" b="0" u="none" strike="noStrike">
-              <a:solidFill>
-                <a:srgbClr val="000000"/>
-              </a:solidFill>
-              <a:effectLst/>
-              <a:uFillTx/>
-              <a:latin typeface="Arial"/>
-            </a:endParaRPr>
-          </a:p>
-        </p:txBody>
-      </p:sp>
-      <p:sp>
-        <p:nvSpPr>
-          <p:cNvPr id="31" name="shape"/>
+            <a:endParaRPr b="0" lang="en-US" sz="3200" spc="-1" strike="noStrike">
+              <a:solidFill>
+                <a:srgbClr val="000000"/>
+              </a:solidFill>
+              <a:latin typeface="Arial"/>
+            </a:endParaRPr>
+          </a:p>
+        </p:txBody>
+      </p:sp>
+      <p:sp>
+        <p:nvSpPr>
+          <p:cNvPr id="29" name="shape"/>
           <p:cNvSpPr txBox="1"/>
           <p:nvPr/>
         </p:nvSpPr>
@@ -2824,41 +2438,32 @@
             <a:avLst/>
           </a:prstGeom>
           <a:solidFill>
-            <a:schemeClr val="accent1"/>
+            <a:srgbClr val="729fcf"/>
           </a:solidFill>
-          <a:ln w="38160">
+          <a:ln w="0">
             <a:solidFill>
-              <a:schemeClr val="accent1">
-                <a:lumMod val="75000"/>
-                <a:lumOff val="0"/>
-              </a:schemeClr>
+              <a:srgbClr val="3465a4"/>
             </a:solidFill>
-            <a:round/>
-          </a:ln>
-        </p:spPr>
-        <p:txBody>
-          <a:bodyPr lIns="90000" tIns="45000" rIns="90000" bIns="45000" anchor="t">
-            <a:spAutoFit/>
-          </a:bodyPr>
-          <a:p>
-            <a:pPr/>
-            <a:r>
-              <a:rPr lang="en-US" sz="1800" b="0" u="none" strike="noStrike">
-                <a:solidFill>
-                  <a:srgbClr val="FFFFFF"/>
-                </a:solidFill>
-                <a:effectLst/>
-                <a:uFillTx/>
+          </a:ln>
+        </p:spPr>
+        <p:txBody>
+          <a:bodyPr lIns="90000" rIns="90000" tIns="45000" bIns="45000" anchor="t">
+            <a:noAutofit/>
+          </a:bodyPr>
+          <a:p>
+            <a:r>
+              <a:rPr b="0" lang="en-US" sz="1800" spc="-1" strike="noStrike">
+                <a:solidFill>
+                  <a:srgbClr val="000000"/>
+                </a:solidFill>
                 <a:latin typeface="Arial"/>
               </a:rPr>
               <a:t>Synthetic slide content 8: Quality Checks.</a:t>
             </a:r>
-            <a:endParaRPr lang="en-US" sz="1800" b="0" u="none" strike="noStrike">
-              <a:solidFill>
-                <a:srgbClr val="FFFFFF"/>
-              </a:solidFill>
-              <a:effectLst/>
-              <a:uFillTx/>
+            <a:endParaRPr b="0" lang="en-US" sz="1800" spc="-1" strike="noStrike">
+              <a:solidFill>
+                <a:srgbClr val="000000"/>
+              </a:solidFill>
               <a:latin typeface="Arial"/>
             </a:endParaRPr>
           </a:p>
@@ -2896,7 +2501,7 @@
       </p:grpSpPr>
       <p:sp>
         <p:nvSpPr>
-          <p:cNvPr id="32" name="title"/>
+          <p:cNvPr id="30" name="title"/>
           <p:cNvSpPr txBox="1"/>
           <p:nvPr/>
         </p:nvSpPr>
@@ -2909,41 +2514,36 @@
             <a:avLst/>
           </a:prstGeom>
           <a:noFill/>
-          <a:ln w="38160">
+          <a:ln w="0">
             <a:noFill/>
           </a:ln>
         </p:spPr>
         <p:txBody>
-          <a:bodyPr lIns="90000" tIns="45000" rIns="90000" bIns="45000" anchor="t">
-            <a:spAutoFit/>
-          </a:bodyPr>
-          <a:p>
-            <a:pPr/>
-            <a:r>
-              <a:rPr lang="en-US" sz="3200" b="1" u="none" strike="noStrike">
-                <a:solidFill>
-                  <a:srgbClr val="000000"/>
-                </a:solidFill>
-                <a:effectLst/>
-                <a:uFillTx/>
+          <a:bodyPr lIns="90000" rIns="90000" tIns="45000" bIns="45000" anchor="t">
+            <a:noAutofit/>
+          </a:bodyPr>
+          <a:p>
+            <a:r>
+              <a:rPr b="1" lang="en-US" sz="3200" spc="-1" strike="noStrike">
+                <a:solidFill>
+                  <a:srgbClr val="000000"/>
+                </a:solidFill>
                 <a:latin typeface="Arial"/>
               </a:rPr>
               <a:t>Data Stewardship</a:t>
             </a:r>
-            <a:endParaRPr lang="en-US" sz="3200" b="0" u="none" strike="noStrike">
-              <a:solidFill>
-                <a:srgbClr val="000000"/>
-              </a:solidFill>
-              <a:effectLst/>
-              <a:uFillTx/>
-              <a:latin typeface="Arial"/>
-            </a:endParaRPr>
-          </a:p>
-        </p:txBody>
-      </p:sp>
-      <p:sp>
-        <p:nvSpPr>
-          <p:cNvPr id="33" name="shape"/>
+            <a:endParaRPr b="0" lang="en-US" sz="3200" spc="-1" strike="noStrike">
+              <a:solidFill>
+                <a:srgbClr val="000000"/>
+              </a:solidFill>
+              <a:latin typeface="Arial"/>
+            </a:endParaRPr>
+          </a:p>
+        </p:txBody>
+      </p:sp>
+      <p:sp>
+        <p:nvSpPr>
+          <p:cNvPr id="31" name="shape"/>
           <p:cNvSpPr txBox="1"/>
           <p:nvPr/>
         </p:nvSpPr>
@@ -2956,41 +2556,32 @@
             <a:avLst/>
           </a:prstGeom>
           <a:solidFill>
-            <a:schemeClr val="accent1"/>
+            <a:srgbClr val="729fcf"/>
           </a:solidFill>
-          <a:ln w="38160">
+          <a:ln w="0">
             <a:solidFill>
-              <a:schemeClr val="accent1">
-                <a:lumMod val="75000"/>
-                <a:lumOff val="0"/>
-              </a:schemeClr>
+              <a:srgbClr val="3465a4"/>
             </a:solidFill>
-            <a:round/>
-          </a:ln>
-        </p:spPr>
-        <p:txBody>
-          <a:bodyPr lIns="90000" tIns="45000" rIns="90000" bIns="45000" anchor="t">
-            <a:spAutoFit/>
-          </a:bodyPr>
-          <a:p>
-            <a:pPr/>
-            <a:r>
-              <a:rPr lang="en-US" sz="1800" b="0" u="none" strike="noStrike">
-                <a:solidFill>
-                  <a:srgbClr val="FFFFFF"/>
-                </a:solidFill>
-                <a:effectLst/>
-                <a:uFillTx/>
+          </a:ln>
+        </p:spPr>
+        <p:txBody>
+          <a:bodyPr lIns="90000" rIns="90000" tIns="45000" bIns="45000" anchor="t">
+            <a:noAutofit/>
+          </a:bodyPr>
+          <a:p>
+            <a:r>
+              <a:rPr b="0" lang="en-US" sz="1800" spc="-1" strike="noStrike">
+                <a:solidFill>
+                  <a:srgbClr val="000000"/>
+                </a:solidFill>
                 <a:latin typeface="Arial"/>
               </a:rPr>
               <a:t>Synthetic slide content 9: Data Stewardship.</a:t>
             </a:r>
-            <a:endParaRPr lang="en-US" sz="1800" b="0" u="none" strike="noStrike">
-              <a:solidFill>
-                <a:srgbClr val="FFFFFF"/>
-              </a:solidFill>
-              <a:effectLst/>
-              <a:uFillTx/>
+            <a:endParaRPr b="0" lang="en-US" sz="1800" spc="-1" strike="noStrike">
+              <a:solidFill>
+                <a:srgbClr val="000000"/>
+              </a:solidFill>
               <a:latin typeface="Arial"/>
             </a:endParaRPr>
           </a:p>
@@ -3017,37 +2608,37 @@
         <a:srgbClr val="000000"/>
       </a:dk1>
       <a:lt1>
-        <a:srgbClr val="FFFFFF"/>
+        <a:srgbClr val="ffffff"/>
       </a:lt1>
       <a:dk2>
         <a:srgbClr val="000000"/>
       </a:dk2>
       <a:lt2>
-        <a:srgbClr val="FFFFFF"/>
+        <a:srgbClr val="ffffff"/>
       </a:lt2>
       <a:accent1>
-        <a:srgbClr val="18A303"/>
+        <a:srgbClr val="18a303"/>
       </a:accent1>
       <a:accent2>
-        <a:srgbClr val="0369A3"/>
+        <a:srgbClr val="0369a3"/>
       </a:accent2>
       <a:accent3>
-        <a:srgbClr val="A33E03"/>
+        <a:srgbClr val="a33e03"/>
       </a:accent3>
       <a:accent4>
-        <a:srgbClr val="8E03A3"/>
+        <a:srgbClr val="8e03a3"/>
       </a:accent4>
       <a:accent5>
-        <a:srgbClr val="C99C00"/>
+        <a:srgbClr val="c99c00"/>
       </a:accent5>
       <a:accent6>
-        <a:srgbClr val="C9211E"/>
+        <a:srgbClr val="c9211e"/>
       </a:accent6>
       <a:hlink>
-        <a:srgbClr val="0000EE"/>
+        <a:srgbClr val="0000ee"/>
       </a:hlink>
       <a:folHlink>
-        <a:srgbClr val="551A8B"/>
+        <a:srgbClr val="551a8b"/>
       </a:folHlink>
     </a:clrScheme>
     <a:fontScheme name="Office">
@@ -3123,37 +2714,37 @@
         <a:srgbClr val="000000"/>
       </a:dk1>
       <a:lt1>
-        <a:srgbClr val="FFFFFF"/>
+        <a:srgbClr val="ffffff"/>
       </a:lt1>
       <a:dk2>
         <a:srgbClr val="000000"/>
       </a:dk2>
       <a:lt2>
-        <a:srgbClr val="FFFFFF"/>
+        <a:srgbClr val="ffffff"/>
       </a:lt2>
       <a:accent1>
-        <a:srgbClr val="18A303"/>
+        <a:srgbClr val="18a303"/>
       </a:accent1>
       <a:accent2>
-        <a:srgbClr val="0369A3"/>
+        <a:srgbClr val="0369a3"/>
       </a:accent2>
       <a:accent3>
-        <a:srgbClr val="A33E03"/>
+        <a:srgbClr val="a33e03"/>
       </a:accent3>
       <a:accent4>
-        <a:srgbClr val="8E03A3"/>
+        <a:srgbClr val="8e03a3"/>
       </a:accent4>
       <a:accent5>
-        <a:srgbClr val="C99C00"/>
+        <a:srgbClr val="c99c00"/>
       </a:accent5>
       <a:accent6>
-        <a:srgbClr val="C9211E"/>
+        <a:srgbClr val="c9211e"/>
       </a:accent6>
       <a:hlink>
-        <a:srgbClr val="0000EE"/>
+        <a:srgbClr val="0000ee"/>
       </a:hlink>
       <a:folHlink>
-        <a:srgbClr val="551A8B"/>
+        <a:srgbClr val="551a8b"/>
       </a:folHlink>
     </a:clrScheme>
     <a:fontScheme name="Office">

</xml_diff>